<commit_message>
Reorganize course structure and update notebooks/slides
- Renumber and rename chapters (e.g. Policy Evaluation/Improvement -> Value-based/Model-based methods)
- Update notes, exercises, and slides across chapters
- Add new papers, drawings, and experiment code
- Regenerate PDFs and remove outdated ones
</commit_message>
<xml_diff>
--- a/02 - The RL Problem/slides.pptx
+++ b/02 - The RL Problem/slides.pptx
@@ -288,1309 +288,37 @@
 </p:presentation>
 </file>
 
-<file path=ppt/revisionInfo.xml><?xml version="1.0" encoding="utf-8"?>
-<p1510:revInfo xmlns:a="http://schemas.openxmlformats.org/drawingml/2006/main" xmlns:r="http://schemas.openxmlformats.org/officeDocument/2006/relationships" xmlns:p1510="http://schemas.microsoft.com/office/powerpoint/2015/10/main">
-  <p1510:revLst>
-    <p1510:client id="{E096B476-39F2-064A-8C8F-231FD45601CE}" v="3" dt="2025-10-02T13:25:19.365"/>
-  </p1510:revLst>
-</p1510:revInfo>
-</file>
-
 <file path=ppt/changesInfos/changesInfo1.xml><?xml version="1.0" encoding="utf-8"?>
 <pc:chgInfo xmlns:a="http://schemas.openxmlformats.org/drawingml/2006/main" xmlns:r="http://schemas.openxmlformats.org/officeDocument/2006/relationships" xmlns:ac="http://schemas.microsoft.com/office/drawing/2013/main/command" xmlns:pc="http://schemas.microsoft.com/office/powerpoint/2013/main/command">
   <pc:docChgLst>
     <pc:chgData name="Riccardo Berta" userId="c8694f89-bba4-4576-b0a8-456619ca5a8c" providerId="ADAL" clId="{FDDBFC5A-5EA9-5330-BEB8-433D7E3B4C4E}"/>
     <pc:docChg chg="custSel modSld">
-      <pc:chgData name="Riccardo Berta" userId="c8694f89-bba4-4576-b0a8-456619ca5a8c" providerId="ADAL" clId="{FDDBFC5A-5EA9-5330-BEB8-433D7E3B4C4E}" dt="2025-10-02T13:29:11.509" v="63" actId="33524"/>
+      <pc:chgData name="Riccardo Berta" userId="c8694f89-bba4-4576-b0a8-456619ca5a8c" providerId="ADAL" clId="{FDDBFC5A-5EA9-5330-BEB8-433D7E3B4C4E}" dt="2026-09-04T12:35:40.090" v="76" actId="20577"/>
       <pc:docMkLst>
         <pc:docMk/>
       </pc:docMkLst>
-      <pc:sldChg chg="modSp mod">
-        <pc:chgData name="Riccardo Berta" userId="c8694f89-bba4-4576-b0a8-456619ca5a8c" providerId="ADAL" clId="{FDDBFC5A-5EA9-5330-BEB8-433D7E3B4C4E}" dt="2025-10-01T05:55:38.308" v="30" actId="20577"/>
-        <pc:sldMkLst>
-          <pc:docMk/>
-          <pc:sldMk cId="2259674710" sldId="267"/>
-        </pc:sldMkLst>
-        <pc:spChg chg="mod">
-          <ac:chgData name="Riccardo Berta" userId="c8694f89-bba4-4576-b0a8-456619ca5a8c" providerId="ADAL" clId="{FDDBFC5A-5EA9-5330-BEB8-433D7E3B4C4E}" dt="2025-10-01T05:55:38.308" v="30" actId="20577"/>
-          <ac:spMkLst>
-            <pc:docMk/>
-            <pc:sldMk cId="2259674710" sldId="267"/>
-            <ac:spMk id="84" creationId="{00000000-0000-0000-0000-000000000000}"/>
-          </ac:spMkLst>
-        </pc:spChg>
-      </pc:sldChg>
-      <pc:sldChg chg="addSp delSp modSp mod">
-        <pc:chgData name="Riccardo Berta" userId="c8694f89-bba4-4576-b0a8-456619ca5a8c" providerId="ADAL" clId="{FDDBFC5A-5EA9-5330-BEB8-433D7E3B4C4E}" dt="2025-10-02T13:25:23.604" v="44" actId="1076"/>
-        <pc:sldMkLst>
-          <pc:docMk/>
-          <pc:sldMk cId="3668836689" sldId="270"/>
-        </pc:sldMkLst>
-        <pc:picChg chg="add del mod">
-          <ac:chgData name="Riccardo Berta" userId="c8694f89-bba4-4576-b0a8-456619ca5a8c" providerId="ADAL" clId="{FDDBFC5A-5EA9-5330-BEB8-433D7E3B4C4E}" dt="2025-10-01T06:02:15.642" v="31" actId="478"/>
-          <ac:picMkLst>
-            <pc:docMk/>
-            <pc:sldMk cId="3668836689" sldId="270"/>
-            <ac:picMk id="2" creationId="{32A5A898-9D3E-8E96-8108-60A79AE3C2DC}"/>
-          </ac:picMkLst>
-        </pc:picChg>
-        <pc:picChg chg="add mod">
-          <ac:chgData name="Riccardo Berta" userId="c8694f89-bba4-4576-b0a8-456619ca5a8c" providerId="ADAL" clId="{FDDBFC5A-5EA9-5330-BEB8-433D7E3B4C4E}" dt="2025-10-02T13:25:23.604" v="44" actId="1076"/>
-          <ac:picMkLst>
-            <pc:docMk/>
-            <pc:sldMk cId="3668836689" sldId="270"/>
-            <ac:picMk id="2" creationId="{C32773A7-DF8F-50CF-3C7F-01A1EBB6DD89}"/>
-          </ac:picMkLst>
-        </pc:picChg>
-        <pc:picChg chg="add del mod">
-          <ac:chgData name="Riccardo Berta" userId="c8694f89-bba4-4576-b0a8-456619ca5a8c" providerId="ADAL" clId="{FDDBFC5A-5EA9-5330-BEB8-433D7E3B4C4E}" dt="2025-10-02T13:25:18.867" v="40" actId="478"/>
-          <ac:picMkLst>
-            <pc:docMk/>
-            <pc:sldMk cId="3668836689" sldId="270"/>
-            <ac:picMk id="3" creationId="{816E9D61-6ED8-3F3E-FC00-F22256E99A51}"/>
-          </ac:picMkLst>
-        </pc:picChg>
-      </pc:sldChg>
-      <pc:sldChg chg="modSp mod">
-        <pc:chgData name="Riccardo Berta" userId="c8694f89-bba4-4576-b0a8-456619ca5a8c" providerId="ADAL" clId="{FDDBFC5A-5EA9-5330-BEB8-433D7E3B4C4E}" dt="2025-10-02T13:28:34.947" v="62" actId="1076"/>
-        <pc:sldMkLst>
-          <pc:docMk/>
-          <pc:sldMk cId="3859598341" sldId="273"/>
-        </pc:sldMkLst>
-        <pc:spChg chg="mod">
-          <ac:chgData name="Riccardo Berta" userId="c8694f89-bba4-4576-b0a8-456619ca5a8c" providerId="ADAL" clId="{FDDBFC5A-5EA9-5330-BEB8-433D7E3B4C4E}" dt="2025-10-02T13:28:04.126" v="60" actId="20577"/>
-          <ac:spMkLst>
-            <pc:docMk/>
-            <pc:sldMk cId="3859598341" sldId="273"/>
-            <ac:spMk id="84" creationId="{00000000-0000-0000-0000-000000000000}"/>
-          </ac:spMkLst>
-        </pc:spChg>
-        <pc:picChg chg="mod">
-          <ac:chgData name="Riccardo Berta" userId="c8694f89-bba4-4576-b0a8-456619ca5a8c" providerId="ADAL" clId="{FDDBFC5A-5EA9-5330-BEB8-433D7E3B4C4E}" dt="2025-10-02T13:28:34.947" v="62" actId="1076"/>
-          <ac:picMkLst>
-            <pc:docMk/>
-            <pc:sldMk cId="3859598341" sldId="273"/>
-            <ac:picMk id="7" creationId="{3AA9CA5E-B11C-5354-F133-CC2410A67F28}"/>
-          </ac:picMkLst>
-        </pc:picChg>
-      </pc:sldChg>
-      <pc:sldChg chg="addSp delSp modSp mod">
-        <pc:chgData name="Riccardo Berta" userId="c8694f89-bba4-4576-b0a8-456619ca5a8c" providerId="ADAL" clId="{FDDBFC5A-5EA9-5330-BEB8-433D7E3B4C4E}" dt="2025-10-02T13:29:11.509" v="63" actId="33524"/>
-        <pc:sldMkLst>
-          <pc:docMk/>
-          <pc:sldMk cId="2213323745" sldId="274"/>
-        </pc:sldMkLst>
-        <pc:spChg chg="mod">
-          <ac:chgData name="Riccardo Berta" userId="c8694f89-bba4-4576-b0a8-456619ca5a8c" providerId="ADAL" clId="{FDDBFC5A-5EA9-5330-BEB8-433D7E3B4C4E}" dt="2025-10-02T13:29:11.509" v="63" actId="33524"/>
-          <ac:spMkLst>
-            <pc:docMk/>
-            <pc:sldMk cId="2213323745" sldId="274"/>
-            <ac:spMk id="84" creationId="{00000000-0000-0000-0000-000000000000}"/>
-          </ac:spMkLst>
-        </pc:spChg>
-        <pc:picChg chg="del">
-          <ac:chgData name="Riccardo Berta" userId="c8694f89-bba4-4576-b0a8-456619ca5a8c" providerId="ADAL" clId="{FDDBFC5A-5EA9-5330-BEB8-433D7E3B4C4E}" dt="2025-10-01T06:09:24.309" v="38" actId="478"/>
-          <ac:picMkLst>
-            <pc:docMk/>
-            <pc:sldMk cId="2213323745" sldId="274"/>
-            <ac:picMk id="3" creationId="{DC8EA310-4CEB-F6CD-8EBA-90EBC000E7D0}"/>
-          </ac:picMkLst>
-        </pc:picChg>
-        <pc:picChg chg="add mod">
-          <ac:chgData name="Riccardo Berta" userId="c8694f89-bba4-4576-b0a8-456619ca5a8c" providerId="ADAL" clId="{FDDBFC5A-5EA9-5330-BEB8-433D7E3B4C4E}" dt="2025-10-01T06:09:30.317" v="39" actId="1076"/>
-          <ac:picMkLst>
-            <pc:docMk/>
-            <pc:sldMk cId="2213323745" sldId="274"/>
-            <ac:picMk id="4" creationId="{63C3FDF9-D634-BF62-C5C2-D932C6B211E9}"/>
-          </ac:picMkLst>
-        </pc:picChg>
-      </pc:sldChg>
-    </pc:docChg>
-  </pc:docChgLst>
-  <pc:docChgLst>
-    <pc:chgData name="Riccardo Berta" userId="c8694f89-bba4-4576-b0a8-456619ca5a8c" providerId="ADAL" clId="{35C5D11B-424E-5B41-A9C4-509DD0A59BFD}"/>
-    <pc:docChg chg="custSel delSld modSld sldOrd">
-      <pc:chgData name="Riccardo Berta" userId="c8694f89-bba4-4576-b0a8-456619ca5a8c" providerId="ADAL" clId="{35C5D11B-424E-5B41-A9C4-509DD0A59BFD}" dt="2022-04-01T12:12:56.906" v="135" actId="20577"/>
-      <pc:docMkLst>
-        <pc:docMk/>
-      </pc:docMkLst>
-      <pc:sldChg chg="modSp">
-        <pc:chgData name="Riccardo Berta" userId="c8694f89-bba4-4576-b0a8-456619ca5a8c" providerId="ADAL" clId="{35C5D11B-424E-5B41-A9C4-509DD0A59BFD}" dt="2022-03-22T07:34:03.014" v="5"/>
+      <pc:sldChg chg="addSp modSp mod">
+        <pc:chgData name="Riccardo Berta" userId="c8694f89-bba4-4576-b0a8-456619ca5a8c" providerId="ADAL" clId="{FDDBFC5A-5EA9-5330-BEB8-433D7E3B4C4E}" dt="2026-09-04T12:35:40.090" v="76" actId="20577"/>
         <pc:sldMkLst>
           <pc:docMk/>
           <pc:sldMk cId="0" sldId="257"/>
         </pc:sldMkLst>
-      </pc:sldChg>
-      <pc:sldChg chg="modSp">
-        <pc:chgData name="Riccardo Berta" userId="c8694f89-bba4-4576-b0a8-456619ca5a8c" providerId="ADAL" clId="{35C5D11B-424E-5B41-A9C4-509DD0A59BFD}" dt="2022-03-22T07:34:23.187" v="6"/>
-        <pc:sldMkLst>
-          <pc:docMk/>
-          <pc:sldMk cId="1899110855" sldId="258"/>
-        </pc:sldMkLst>
-      </pc:sldChg>
-      <pc:sldChg chg="modSp">
-        <pc:chgData name="Riccardo Berta" userId="c8694f89-bba4-4576-b0a8-456619ca5a8c" providerId="ADAL" clId="{35C5D11B-424E-5B41-A9C4-509DD0A59BFD}" dt="2022-03-22T07:39:20.191" v="16"/>
-        <pc:sldMkLst>
-          <pc:docMk/>
-          <pc:sldMk cId="3018556184" sldId="259"/>
-        </pc:sldMkLst>
-      </pc:sldChg>
-      <pc:sldChg chg="modSp mod">
-        <pc:chgData name="Riccardo Berta" userId="c8694f89-bba4-4576-b0a8-456619ca5a8c" providerId="ADAL" clId="{35C5D11B-424E-5B41-A9C4-509DD0A59BFD}" dt="2022-03-23T07:58:19.601" v="41" actId="20577"/>
-        <pc:sldMkLst>
-          <pc:docMk/>
-          <pc:sldMk cId="1104208334" sldId="260"/>
-        </pc:sldMkLst>
-      </pc:sldChg>
-      <pc:sldChg chg="modSp">
-        <pc:chgData name="Riccardo Berta" userId="c8694f89-bba4-4576-b0a8-456619ca5a8c" providerId="ADAL" clId="{35C5D11B-424E-5B41-A9C4-509DD0A59BFD}" dt="2022-03-22T07:42:45.729" v="19"/>
-        <pc:sldMkLst>
-          <pc:docMk/>
-          <pc:sldMk cId="1290395919" sldId="261"/>
-        </pc:sldMkLst>
-      </pc:sldChg>
-      <pc:sldChg chg="modSp mod modNotes">
-        <pc:chgData name="Riccardo Berta" userId="c8694f89-bba4-4576-b0a8-456619ca5a8c" providerId="ADAL" clId="{35C5D11B-424E-5B41-A9C4-509DD0A59BFD}" dt="2022-03-25T14:38:53.205" v="88" actId="20577"/>
-        <pc:sldMkLst>
-          <pc:docMk/>
-          <pc:sldMk cId="4130549615" sldId="262"/>
-        </pc:sldMkLst>
-      </pc:sldChg>
-      <pc:sldChg chg="modSp">
-        <pc:chgData name="Riccardo Berta" userId="c8694f89-bba4-4576-b0a8-456619ca5a8c" providerId="ADAL" clId="{35C5D11B-424E-5B41-A9C4-509DD0A59BFD}" dt="2022-03-22T07:43:16.691" v="21"/>
-        <pc:sldMkLst>
-          <pc:docMk/>
-          <pc:sldMk cId="3102138681" sldId="263"/>
-        </pc:sldMkLst>
-      </pc:sldChg>
-      <pc:sldChg chg="modSp mod">
-        <pc:chgData name="Riccardo Berta" userId="c8694f89-bba4-4576-b0a8-456619ca5a8c" providerId="ADAL" clId="{35C5D11B-424E-5B41-A9C4-509DD0A59BFD}" dt="2022-03-25T15:16:54.434" v="126" actId="20577"/>
-        <pc:sldMkLst>
-          <pc:docMk/>
-          <pc:sldMk cId="2113557187" sldId="264"/>
-        </pc:sldMkLst>
-      </pc:sldChg>
-      <pc:sldChg chg="modSp">
-        <pc:chgData name="Riccardo Berta" userId="c8694f89-bba4-4576-b0a8-456619ca5a8c" providerId="ADAL" clId="{35C5D11B-424E-5B41-A9C4-509DD0A59BFD}" dt="2022-03-22T07:44:03.240" v="24"/>
-        <pc:sldMkLst>
-          <pc:docMk/>
-          <pc:sldMk cId="2045385232" sldId="265"/>
-        </pc:sldMkLst>
-      </pc:sldChg>
-      <pc:sldChg chg="modSp">
-        <pc:chgData name="Riccardo Berta" userId="c8694f89-bba4-4576-b0a8-456619ca5a8c" providerId="ADAL" clId="{35C5D11B-424E-5B41-A9C4-509DD0A59BFD}" dt="2022-03-22T07:44:22.734" v="25"/>
-        <pc:sldMkLst>
-          <pc:docMk/>
-          <pc:sldMk cId="4181844165" sldId="266"/>
-        </pc:sldMkLst>
-      </pc:sldChg>
-      <pc:sldChg chg="modSp mod">
-        <pc:chgData name="Riccardo Berta" userId="c8694f89-bba4-4576-b0a8-456619ca5a8c" providerId="ADAL" clId="{35C5D11B-424E-5B41-A9C4-509DD0A59BFD}" dt="2022-04-01T12:12:56.906" v="135" actId="20577"/>
-        <pc:sldMkLst>
-          <pc:docMk/>
-          <pc:sldMk cId="216455838" sldId="267"/>
-        </pc:sldMkLst>
-      </pc:sldChg>
-      <pc:sldChg chg="del">
-        <pc:chgData name="Riccardo Berta" userId="c8694f89-bba4-4576-b0a8-456619ca5a8c" providerId="ADAL" clId="{35C5D11B-424E-5B41-A9C4-509DD0A59BFD}" dt="2022-03-22T07:29:13.529" v="3" actId="2696"/>
-        <pc:sldMkLst>
-          <pc:docMk/>
-          <pc:sldMk cId="925286286" sldId="268"/>
-        </pc:sldMkLst>
-      </pc:sldChg>
-      <pc:sldChg chg="modSp">
-        <pc:chgData name="Riccardo Berta" userId="c8694f89-bba4-4576-b0a8-456619ca5a8c" providerId="ADAL" clId="{35C5D11B-424E-5B41-A9C4-509DD0A59BFD}" dt="2022-03-22T07:44:59.403" v="28"/>
-        <pc:sldMkLst>
-          <pc:docMk/>
-          <pc:sldMk cId="3471997037" sldId="269"/>
-        </pc:sldMkLst>
-      </pc:sldChg>
-      <pc:sldChg chg="modSp mod">
-        <pc:chgData name="Riccardo Berta" userId="c8694f89-bba4-4576-b0a8-456619ca5a8c" providerId="ADAL" clId="{35C5D11B-424E-5B41-A9C4-509DD0A59BFD}" dt="2022-03-22T07:47:03.443" v="33"/>
-        <pc:sldMkLst>
-          <pc:docMk/>
-          <pc:sldMk cId="3130917410" sldId="270"/>
-        </pc:sldMkLst>
-      </pc:sldChg>
-      <pc:sldChg chg="modSp mod">
-        <pc:chgData name="Riccardo Berta" userId="c8694f89-bba4-4576-b0a8-456619ca5a8c" providerId="ADAL" clId="{35C5D11B-424E-5B41-A9C4-509DD0A59BFD}" dt="2022-03-22T07:47:51.976" v="38"/>
-        <pc:sldMkLst>
-          <pc:docMk/>
-          <pc:sldMk cId="2266699268" sldId="271"/>
-        </pc:sldMkLst>
-      </pc:sldChg>
-      <pc:sldChg chg="modSp mod ord">
-        <pc:chgData name="Riccardo Berta" userId="c8694f89-bba4-4576-b0a8-456619ca5a8c" providerId="ADAL" clId="{35C5D11B-424E-5B41-A9C4-509DD0A59BFD}" dt="2022-03-22T07:29:04.952" v="2"/>
-        <pc:sldMkLst>
-          <pc:docMk/>
-          <pc:sldMk cId="993270251" sldId="272"/>
-        </pc:sldMkLst>
-      </pc:sldChg>
-      <pc:sldChg chg="modSp">
-        <pc:chgData name="Riccardo Berta" userId="c8694f89-bba4-4576-b0a8-456619ca5a8c" providerId="ADAL" clId="{35C5D11B-424E-5B41-A9C4-509DD0A59BFD}" dt="2022-03-22T07:48:04.230" v="39"/>
-        <pc:sldMkLst>
-          <pc:docMk/>
-          <pc:sldMk cId="3843819371" sldId="273"/>
-        </pc:sldMkLst>
-      </pc:sldChg>
-      <pc:sldChg chg="modSp">
-        <pc:chgData name="Riccardo Berta" userId="c8694f89-bba4-4576-b0a8-456619ca5a8c" providerId="ADAL" clId="{35C5D11B-424E-5B41-A9C4-509DD0A59BFD}" dt="2022-03-22T07:48:21.111" v="40"/>
-        <pc:sldMkLst>
-          <pc:docMk/>
-          <pc:sldMk cId="284781631" sldId="275"/>
-        </pc:sldMkLst>
-      </pc:sldChg>
-    </pc:docChg>
-  </pc:docChgLst>
-  <pc:docChgLst>
-    <pc:chgData name="Riccardo Berta" userId="c8694f89-bba4-4576-b0a8-456619ca5a8c" providerId="ADAL" clId="{4967B734-A465-2844-BA15-7FBACE49D2F8}"/>
-    <pc:docChg chg="undo redo custSel addSld delSld modSld sldOrd">
-      <pc:chgData name="Riccardo Berta" userId="c8694f89-bba4-4576-b0a8-456619ca5a8c" providerId="ADAL" clId="{4967B734-A465-2844-BA15-7FBACE49D2F8}" dt="2022-10-10T07:13:16.328" v="2720" actId="403"/>
-      <pc:docMkLst>
-        <pc:docMk/>
-      </pc:docMkLst>
-      <pc:sldChg chg="modSp mod">
-        <pc:chgData name="Riccardo Berta" userId="c8694f89-bba4-4576-b0a8-456619ca5a8c" providerId="ADAL" clId="{4967B734-A465-2844-BA15-7FBACE49D2F8}" dt="2022-10-04T09:21:06.296" v="1514" actId="790"/>
-        <pc:sldMkLst>
-          <pc:docMk/>
-          <pc:sldMk cId="0" sldId="256"/>
-        </pc:sldMkLst>
-      </pc:sldChg>
-      <pc:sldChg chg="delSp modSp mod">
-        <pc:chgData name="Riccardo Berta" userId="c8694f89-bba4-4576-b0a8-456619ca5a8c" providerId="ADAL" clId="{4967B734-A465-2844-BA15-7FBACE49D2F8}" dt="2022-10-05T05:37:06.487" v="2566" actId="20577"/>
-        <pc:sldMkLst>
-          <pc:docMk/>
-          <pc:sldMk cId="0" sldId="257"/>
-        </pc:sldMkLst>
-      </pc:sldChg>
-      <pc:sldChg chg="del">
-        <pc:chgData name="Riccardo Berta" userId="c8694f89-bba4-4576-b0a8-456619ca5a8c" providerId="ADAL" clId="{4967B734-A465-2844-BA15-7FBACE49D2F8}" dt="2022-10-04T06:54:03.310" v="50" actId="2696"/>
-        <pc:sldMkLst>
-          <pc:docMk/>
-          <pc:sldMk cId="3018556184" sldId="259"/>
-        </pc:sldMkLst>
-      </pc:sldChg>
-      <pc:sldChg chg="del">
-        <pc:chgData name="Riccardo Berta" userId="c8694f89-bba4-4576-b0a8-456619ca5a8c" providerId="ADAL" clId="{4967B734-A465-2844-BA15-7FBACE49D2F8}" dt="2022-10-04T06:54:03.809" v="51" actId="2696"/>
-        <pc:sldMkLst>
-          <pc:docMk/>
-          <pc:sldMk cId="723946338" sldId="261"/>
-        </pc:sldMkLst>
-      </pc:sldChg>
-      <pc:sldChg chg="modSp mod">
-        <pc:chgData name="Riccardo Berta" userId="c8694f89-bba4-4576-b0a8-456619ca5a8c" providerId="ADAL" clId="{4967B734-A465-2844-BA15-7FBACE49D2F8}" dt="2022-10-10T07:13:16.328" v="2720" actId="403"/>
-        <pc:sldMkLst>
-          <pc:docMk/>
-          <pc:sldMk cId="0" sldId="264"/>
-        </pc:sldMkLst>
-      </pc:sldChg>
-      <pc:sldChg chg="del">
-        <pc:chgData name="Riccardo Berta" userId="c8694f89-bba4-4576-b0a8-456619ca5a8c" providerId="ADAL" clId="{4967B734-A465-2844-BA15-7FBACE49D2F8}" dt="2022-10-04T06:54:04.269" v="52" actId="2696"/>
-        <pc:sldMkLst>
-          <pc:docMk/>
-          <pc:sldMk cId="2752186034" sldId="265"/>
-        </pc:sldMkLst>
-      </pc:sldChg>
-      <pc:sldChg chg="addSp modSp add mod">
-        <pc:chgData name="Riccardo Berta" userId="c8694f89-bba4-4576-b0a8-456619ca5a8c" providerId="ADAL" clId="{4967B734-A465-2844-BA15-7FBACE49D2F8}" dt="2022-10-05T05:38:43.218" v="2573" actId="20577"/>
-        <pc:sldMkLst>
-          <pc:docMk/>
-          <pc:sldMk cId="4260925133" sldId="265"/>
-        </pc:sldMkLst>
-      </pc:sldChg>
-      <pc:sldChg chg="addSp delSp modSp add mod">
-        <pc:chgData name="Riccardo Berta" userId="c8694f89-bba4-4576-b0a8-456619ca5a8c" providerId="ADAL" clId="{4967B734-A465-2844-BA15-7FBACE49D2F8}" dt="2022-10-05T05:43:30.967" v="2628" actId="20577"/>
-        <pc:sldMkLst>
-          <pc:docMk/>
-          <pc:sldMk cId="2074499598" sldId="266"/>
-        </pc:sldMkLst>
-      </pc:sldChg>
-      <pc:sldChg chg="addSp delSp modSp add mod ord">
-        <pc:chgData name="Riccardo Berta" userId="c8694f89-bba4-4576-b0a8-456619ca5a8c" providerId="ADAL" clId="{4967B734-A465-2844-BA15-7FBACE49D2F8}" dt="2022-10-05T05:40:18.404" v="2582" actId="20577"/>
-        <pc:sldMkLst>
-          <pc:docMk/>
-          <pc:sldMk cId="2259674710" sldId="267"/>
-        </pc:sldMkLst>
-      </pc:sldChg>
-      <pc:sldChg chg="addSp delSp modSp add mod ord">
-        <pc:chgData name="Riccardo Berta" userId="c8694f89-bba4-4576-b0a8-456619ca5a8c" providerId="ADAL" clId="{4967B734-A465-2844-BA15-7FBACE49D2F8}" dt="2022-10-04T08:21:03.314" v="615" actId="20577"/>
-        <pc:sldMkLst>
-          <pc:docMk/>
-          <pc:sldMk cId="2756532613" sldId="268"/>
-        </pc:sldMkLst>
-      </pc:sldChg>
-      <pc:sldChg chg="addSp delSp modSp add mod ord">
-        <pc:chgData name="Riccardo Berta" userId="c8694f89-bba4-4576-b0a8-456619ca5a8c" providerId="ADAL" clId="{4967B734-A465-2844-BA15-7FBACE49D2F8}" dt="2022-10-04T08:22:30.428" v="629" actId="20577"/>
-        <pc:sldMkLst>
-          <pc:docMk/>
-          <pc:sldMk cId="3950372499" sldId="269"/>
-        </pc:sldMkLst>
-      </pc:sldChg>
-      <pc:sldChg chg="addSp delSp modSp add mod">
-        <pc:chgData name="Riccardo Berta" userId="c8694f89-bba4-4576-b0a8-456619ca5a8c" providerId="ADAL" clId="{4967B734-A465-2844-BA15-7FBACE49D2F8}" dt="2022-10-04T08:30:10.946" v="871" actId="1076"/>
-        <pc:sldMkLst>
-          <pc:docMk/>
-          <pc:sldMk cId="3668836689" sldId="270"/>
-        </pc:sldMkLst>
-      </pc:sldChg>
-      <pc:sldChg chg="addSp modSp add mod">
-        <pc:chgData name="Riccardo Berta" userId="c8694f89-bba4-4576-b0a8-456619ca5a8c" providerId="ADAL" clId="{4967B734-A465-2844-BA15-7FBACE49D2F8}" dt="2022-10-04T08:33:08.776" v="912" actId="1076"/>
-        <pc:sldMkLst>
-          <pc:docMk/>
-          <pc:sldMk cId="1894295752" sldId="271"/>
-        </pc:sldMkLst>
-      </pc:sldChg>
-      <pc:sldChg chg="del">
-        <pc:chgData name="Riccardo Berta" userId="c8694f89-bba4-4576-b0a8-456619ca5a8c" providerId="ADAL" clId="{4967B734-A465-2844-BA15-7FBACE49D2F8}" dt="2022-10-04T06:54:05.175" v="54" actId="2696"/>
-        <pc:sldMkLst>
-          <pc:docMk/>
-          <pc:sldMk cId="1942012932" sldId="271"/>
-        </pc:sldMkLst>
-      </pc:sldChg>
-      <pc:sldChg chg="addSp modSp add mod">
-        <pc:chgData name="Riccardo Berta" userId="c8694f89-bba4-4576-b0a8-456619ca5a8c" providerId="ADAL" clId="{4967B734-A465-2844-BA15-7FBACE49D2F8}" dt="2022-10-05T05:45:21.155" v="2636" actId="20577"/>
-        <pc:sldMkLst>
-          <pc:docMk/>
-          <pc:sldMk cId="732868139" sldId="272"/>
-        </pc:sldMkLst>
-      </pc:sldChg>
-      <pc:sldChg chg="addSp delSp modSp add mod">
-        <pc:chgData name="Riccardo Berta" userId="c8694f89-bba4-4576-b0a8-456619ca5a8c" providerId="ADAL" clId="{4967B734-A465-2844-BA15-7FBACE49D2F8}" dt="2022-10-04T08:54:59.469" v="1509" actId="20577"/>
-        <pc:sldMkLst>
-          <pc:docMk/>
-          <pc:sldMk cId="3859598341" sldId="273"/>
-        </pc:sldMkLst>
-      </pc:sldChg>
-      <pc:sldChg chg="addSp modSp add mod">
-        <pc:chgData name="Riccardo Berta" userId="c8694f89-bba4-4576-b0a8-456619ca5a8c" providerId="ADAL" clId="{4967B734-A465-2844-BA15-7FBACE49D2F8}" dt="2022-10-04T08:55:10.050" v="1510" actId="1076"/>
-        <pc:sldMkLst>
-          <pc:docMk/>
-          <pc:sldMk cId="2213323745" sldId="274"/>
-        </pc:sldMkLst>
-      </pc:sldChg>
-      <pc:sldChg chg="del">
-        <pc:chgData name="Riccardo Berta" userId="c8694f89-bba4-4576-b0a8-456619ca5a8c" providerId="ADAL" clId="{4967B734-A465-2844-BA15-7FBACE49D2F8}" dt="2022-10-04T06:54:05.569" v="55" actId="2696"/>
-        <pc:sldMkLst>
-          <pc:docMk/>
-          <pc:sldMk cId="2759966790" sldId="274"/>
-        </pc:sldMkLst>
-      </pc:sldChg>
-      <pc:sldChg chg="addSp modSp add mod">
-        <pc:chgData name="Riccardo Berta" userId="c8694f89-bba4-4576-b0a8-456619ca5a8c" providerId="ADAL" clId="{4967B734-A465-2844-BA15-7FBACE49D2F8}" dt="2022-10-10T05:36:43.547" v="2688" actId="20577"/>
-        <pc:sldMkLst>
-          <pc:docMk/>
-          <pc:sldMk cId="303121765" sldId="275"/>
-        </pc:sldMkLst>
-      </pc:sldChg>
-      <pc:sldChg chg="del">
-        <pc:chgData name="Riccardo Berta" userId="c8694f89-bba4-4576-b0a8-456619ca5a8c" providerId="ADAL" clId="{4967B734-A465-2844-BA15-7FBACE49D2F8}" dt="2022-10-04T06:54:06.082" v="56" actId="2696"/>
-        <pc:sldMkLst>
-          <pc:docMk/>
-          <pc:sldMk cId="3965473342" sldId="275"/>
-        </pc:sldMkLst>
-      </pc:sldChg>
-      <pc:sldChg chg="addSp modSp add mod">
-        <pc:chgData name="Riccardo Berta" userId="c8694f89-bba4-4576-b0a8-456619ca5a8c" providerId="ADAL" clId="{4967B734-A465-2844-BA15-7FBACE49D2F8}" dt="2022-10-04T09:35:09.338" v="1844" actId="113"/>
-        <pc:sldMkLst>
-          <pc:docMk/>
-          <pc:sldMk cId="2020526202" sldId="276"/>
-        </pc:sldMkLst>
-      </pc:sldChg>
-      <pc:sldChg chg="del">
-        <pc:chgData name="Riccardo Berta" userId="c8694f89-bba4-4576-b0a8-456619ca5a8c" providerId="ADAL" clId="{4967B734-A465-2844-BA15-7FBACE49D2F8}" dt="2022-10-04T06:54:06.650" v="57" actId="2696"/>
-        <pc:sldMkLst>
-          <pc:docMk/>
-          <pc:sldMk cId="3364334937" sldId="276"/>
-        </pc:sldMkLst>
-      </pc:sldChg>
-      <pc:sldChg chg="del">
-        <pc:chgData name="Riccardo Berta" userId="c8694f89-bba4-4576-b0a8-456619ca5a8c" providerId="ADAL" clId="{4967B734-A465-2844-BA15-7FBACE49D2F8}" dt="2022-10-04T06:54:07.117" v="58" actId="2696"/>
-        <pc:sldMkLst>
-          <pc:docMk/>
-          <pc:sldMk cId="2920432797" sldId="277"/>
-        </pc:sldMkLst>
-      </pc:sldChg>
-      <pc:sldChg chg="addSp modSp add mod">
-        <pc:chgData name="Riccardo Berta" userId="c8694f89-bba4-4576-b0a8-456619ca5a8c" providerId="ADAL" clId="{4967B734-A465-2844-BA15-7FBACE49D2F8}" dt="2022-10-10T05:38:42.742" v="2693" actId="20577"/>
-        <pc:sldMkLst>
-          <pc:docMk/>
-          <pc:sldMk cId="3156887330" sldId="277"/>
-        </pc:sldMkLst>
-      </pc:sldChg>
-      <pc:sldChg chg="addSp modSp add mod">
-        <pc:chgData name="Riccardo Berta" userId="c8694f89-bba4-4576-b0a8-456619ca5a8c" providerId="ADAL" clId="{4967B734-A465-2844-BA15-7FBACE49D2F8}" dt="2022-10-04T09:50:43.485" v="2061" actId="1076"/>
-        <pc:sldMkLst>
-          <pc:docMk/>
-          <pc:sldMk cId="1586284290" sldId="278"/>
-        </pc:sldMkLst>
-      </pc:sldChg>
-      <pc:sldChg chg="del">
-        <pc:chgData name="Riccardo Berta" userId="c8694f89-bba4-4576-b0a8-456619ca5a8c" providerId="ADAL" clId="{4967B734-A465-2844-BA15-7FBACE49D2F8}" dt="2022-10-04T06:54:07.594" v="59" actId="2696"/>
-        <pc:sldMkLst>
-          <pc:docMk/>
-          <pc:sldMk cId="3024273348" sldId="278"/>
-        </pc:sldMkLst>
-      </pc:sldChg>
-      <pc:sldChg chg="del">
-        <pc:chgData name="Riccardo Berta" userId="c8694f89-bba4-4576-b0a8-456619ca5a8c" providerId="ADAL" clId="{4967B734-A465-2844-BA15-7FBACE49D2F8}" dt="2022-10-04T06:54:08.017" v="60" actId="2696"/>
-        <pc:sldMkLst>
-          <pc:docMk/>
-          <pc:sldMk cId="2505677359" sldId="279"/>
-        </pc:sldMkLst>
-      </pc:sldChg>
-      <pc:sldChg chg="modSp add mod">
-        <pc:chgData name="Riccardo Berta" userId="c8694f89-bba4-4576-b0a8-456619ca5a8c" providerId="ADAL" clId="{4967B734-A465-2844-BA15-7FBACE49D2F8}" dt="2022-10-04T09:56:29.719" v="2268" actId="404"/>
-        <pc:sldMkLst>
-          <pc:docMk/>
-          <pc:sldMk cId="2677523252" sldId="279"/>
-        </pc:sldMkLst>
-      </pc:sldChg>
-      <pc:sldChg chg="addSp delSp modSp add mod">
-        <pc:chgData name="Riccardo Berta" userId="c8694f89-bba4-4576-b0a8-456619ca5a8c" providerId="ADAL" clId="{4967B734-A465-2844-BA15-7FBACE49D2F8}" dt="2022-10-10T05:41:52.141" v="2700" actId="1036"/>
-        <pc:sldMkLst>
-          <pc:docMk/>
-          <pc:sldMk cId="635836889" sldId="280"/>
-        </pc:sldMkLst>
-      </pc:sldChg>
-      <pc:sldChg chg="del">
-        <pc:chgData name="Riccardo Berta" userId="c8694f89-bba4-4576-b0a8-456619ca5a8c" providerId="ADAL" clId="{4967B734-A465-2844-BA15-7FBACE49D2F8}" dt="2022-10-04T06:54:08.481" v="61" actId="2696"/>
-        <pc:sldMkLst>
-          <pc:docMk/>
-          <pc:sldMk cId="3525330065" sldId="280"/>
-        </pc:sldMkLst>
-      </pc:sldChg>
-      <pc:sldChg chg="del">
-        <pc:chgData name="Riccardo Berta" userId="c8694f89-bba4-4576-b0a8-456619ca5a8c" providerId="ADAL" clId="{4967B734-A465-2844-BA15-7FBACE49D2F8}" dt="2022-10-04T06:54:08.911" v="62" actId="2696"/>
-        <pc:sldMkLst>
-          <pc:docMk/>
-          <pc:sldMk cId="349541788" sldId="281"/>
-        </pc:sldMkLst>
-      </pc:sldChg>
-      <pc:sldChg chg="addSp modSp add mod">
-        <pc:chgData name="Riccardo Berta" userId="c8694f89-bba4-4576-b0a8-456619ca5a8c" providerId="ADAL" clId="{4967B734-A465-2844-BA15-7FBACE49D2F8}" dt="2022-10-04T10:06:15.809" v="2385" actId="1076"/>
-        <pc:sldMkLst>
-          <pc:docMk/>
-          <pc:sldMk cId="2288803032" sldId="281"/>
-        </pc:sldMkLst>
-      </pc:sldChg>
-      <pc:sldChg chg="addSp delSp modSp add mod">
-        <pc:chgData name="Riccardo Berta" userId="c8694f89-bba4-4576-b0a8-456619ca5a8c" providerId="ADAL" clId="{4967B734-A465-2844-BA15-7FBACE49D2F8}" dt="2022-10-04T10:16:31.835" v="2463" actId="20577"/>
-        <pc:sldMkLst>
-          <pc:docMk/>
-          <pc:sldMk cId="663506827" sldId="282"/>
-        </pc:sldMkLst>
-      </pc:sldChg>
-      <pc:sldChg chg="del">
-        <pc:chgData name="Riccardo Berta" userId="c8694f89-bba4-4576-b0a8-456619ca5a8c" providerId="ADAL" clId="{4967B734-A465-2844-BA15-7FBACE49D2F8}" dt="2022-10-04T06:54:09.464" v="63" actId="2696"/>
-        <pc:sldMkLst>
-          <pc:docMk/>
-          <pc:sldMk cId="2584172506" sldId="282"/>
-        </pc:sldMkLst>
-      </pc:sldChg>
-      <pc:sldChg chg="addSp delSp modSp add mod">
-        <pc:chgData name="Riccardo Berta" userId="c8694f89-bba4-4576-b0a8-456619ca5a8c" providerId="ADAL" clId="{4967B734-A465-2844-BA15-7FBACE49D2F8}" dt="2022-10-04T10:17:39.088" v="2550" actId="20577"/>
-        <pc:sldMkLst>
-          <pc:docMk/>
-          <pc:sldMk cId="2423864326" sldId="283"/>
-        </pc:sldMkLst>
-      </pc:sldChg>
-      <pc:sldChg chg="del">
-        <pc:chgData name="Riccardo Berta" userId="c8694f89-bba4-4576-b0a8-456619ca5a8c" providerId="ADAL" clId="{4967B734-A465-2844-BA15-7FBACE49D2F8}" dt="2022-10-04T06:54:09.892" v="64" actId="2696"/>
-        <pc:sldMkLst>
-          <pc:docMk/>
-          <pc:sldMk cId="2548826204" sldId="283"/>
-        </pc:sldMkLst>
-      </pc:sldChg>
-      <pc:sldChg chg="add del">
-        <pc:chgData name="Riccardo Berta" userId="c8694f89-bba4-4576-b0a8-456619ca5a8c" providerId="ADAL" clId="{4967B734-A465-2844-BA15-7FBACE49D2F8}" dt="2022-10-04T10:14:48.405" v="2429"/>
-        <pc:sldMkLst>
-          <pc:docMk/>
-          <pc:sldMk cId="196183857" sldId="284"/>
-        </pc:sldMkLst>
-      </pc:sldChg>
-      <pc:sldChg chg="addSp delSp modSp add mod">
-        <pc:chgData name="Riccardo Berta" userId="c8694f89-bba4-4576-b0a8-456619ca5a8c" providerId="ADAL" clId="{4967B734-A465-2844-BA15-7FBACE49D2F8}" dt="2022-10-04T10:16:23.053" v="2461" actId="1076"/>
-        <pc:sldMkLst>
-          <pc:docMk/>
-          <pc:sldMk cId="852930802" sldId="284"/>
-        </pc:sldMkLst>
-      </pc:sldChg>
-      <pc:sldChg chg="del">
-        <pc:chgData name="Riccardo Berta" userId="c8694f89-bba4-4576-b0a8-456619ca5a8c" providerId="ADAL" clId="{4967B734-A465-2844-BA15-7FBACE49D2F8}" dt="2022-10-04T06:54:10.321" v="65" actId="2696"/>
-        <pc:sldMkLst>
-          <pc:docMk/>
-          <pc:sldMk cId="3494619461" sldId="284"/>
-        </pc:sldMkLst>
-      </pc:sldChg>
-      <pc:sldChg chg="add">
-        <pc:chgData name="Riccardo Berta" userId="c8694f89-bba4-4576-b0a8-456619ca5a8c" providerId="ADAL" clId="{4967B734-A465-2844-BA15-7FBACE49D2F8}" dt="2022-10-10T06:49:42.934" v="2718"/>
-        <pc:sldMkLst>
-          <pc:docMk/>
-          <pc:sldMk cId="1602265730" sldId="285"/>
-        </pc:sldMkLst>
-      </pc:sldChg>
-      <pc:sldChg chg="del">
-        <pc:chgData name="Riccardo Berta" userId="c8694f89-bba4-4576-b0a8-456619ca5a8c" providerId="ADAL" clId="{4967B734-A465-2844-BA15-7FBACE49D2F8}" dt="2022-10-04T06:54:10.985" v="66" actId="2696"/>
-        <pc:sldMkLst>
-          <pc:docMk/>
-          <pc:sldMk cId="3458162749" sldId="285"/>
-        </pc:sldMkLst>
-      </pc:sldChg>
-      <pc:sldChg chg="add">
-        <pc:chgData name="Riccardo Berta" userId="c8694f89-bba4-4576-b0a8-456619ca5a8c" providerId="ADAL" clId="{4967B734-A465-2844-BA15-7FBACE49D2F8}" dt="2022-10-10T06:49:52.734" v="2719"/>
-        <pc:sldMkLst>
-          <pc:docMk/>
-          <pc:sldMk cId="0" sldId="286"/>
-        </pc:sldMkLst>
-      </pc:sldChg>
-      <pc:sldChg chg="del">
-        <pc:chgData name="Riccardo Berta" userId="c8694f89-bba4-4576-b0a8-456619ca5a8c" providerId="ADAL" clId="{4967B734-A465-2844-BA15-7FBACE49D2F8}" dt="2022-10-04T06:54:13.372" v="69" actId="2696"/>
-        <pc:sldMkLst>
-          <pc:docMk/>
-          <pc:sldMk cId="3186725423" sldId="286"/>
-        </pc:sldMkLst>
-      </pc:sldChg>
-      <pc:sldChg chg="del">
-        <pc:chgData name="Riccardo Berta" userId="c8694f89-bba4-4576-b0a8-456619ca5a8c" providerId="ADAL" clId="{4967B734-A465-2844-BA15-7FBACE49D2F8}" dt="2022-10-04T06:54:04.705" v="53" actId="2696"/>
-        <pc:sldMkLst>
-          <pc:docMk/>
-          <pc:sldMk cId="1166550415" sldId="288"/>
-        </pc:sldMkLst>
-      </pc:sldChg>
-      <pc:sldChg chg="del">
-        <pc:chgData name="Riccardo Berta" userId="c8694f89-bba4-4576-b0a8-456619ca5a8c" providerId="ADAL" clId="{4967B734-A465-2844-BA15-7FBACE49D2F8}" dt="2022-10-04T06:54:12.030" v="67" actId="2696"/>
-        <pc:sldMkLst>
-          <pc:docMk/>
-          <pc:sldMk cId="0" sldId="344"/>
-        </pc:sldMkLst>
-      </pc:sldChg>
-      <pc:sldChg chg="del">
-        <pc:chgData name="Riccardo Berta" userId="c8694f89-bba4-4576-b0a8-456619ca5a8c" providerId="ADAL" clId="{4967B734-A465-2844-BA15-7FBACE49D2F8}" dt="2022-10-04T06:54:12.601" v="68" actId="2696"/>
-        <pc:sldMkLst>
-          <pc:docMk/>
-          <pc:sldMk cId="615642029" sldId="403"/>
-        </pc:sldMkLst>
-      </pc:sldChg>
-      <pc:sldMasterChg chg="delSldLayout">
-        <pc:chgData name="Riccardo Berta" userId="c8694f89-bba4-4576-b0a8-456619ca5a8c" providerId="ADAL" clId="{4967B734-A465-2844-BA15-7FBACE49D2F8}" dt="2022-10-04T06:54:12.601" v="68" actId="2696"/>
-        <pc:sldMasterMkLst>
-          <pc:docMk/>
-          <pc:sldMasterMk cId="0" sldId="2147483659"/>
-        </pc:sldMasterMkLst>
-        <pc:sldLayoutChg chg="del">
-          <pc:chgData name="Riccardo Berta" userId="c8694f89-bba4-4576-b0a8-456619ca5a8c" providerId="ADAL" clId="{4967B734-A465-2844-BA15-7FBACE49D2F8}" dt="2022-10-04T06:54:12.601" v="68" actId="2696"/>
-          <pc:sldLayoutMkLst>
+        <pc:spChg chg="mod">
+          <ac:chgData name="Riccardo Berta" userId="c8694f89-bba4-4576-b0a8-456619ca5a8c" providerId="ADAL" clId="{FDDBFC5A-5EA9-5330-BEB8-433D7E3B4C4E}" dt="2026-09-04T12:35:40.090" v="76" actId="20577"/>
+          <ac:spMkLst>
             <pc:docMk/>
-            <pc:sldMasterMk cId="0" sldId="2147483659"/>
-            <pc:sldLayoutMk cId="2937273629" sldId="2147483660"/>
-          </pc:sldLayoutMkLst>
-        </pc:sldLayoutChg>
-      </pc:sldMasterChg>
-    </pc:docChg>
-  </pc:docChgLst>
-  <pc:docChgLst>
-    <pc:chgData name="Riccardo Berta" userId="c8694f89-bba4-4576-b0a8-456619ca5a8c" providerId="ADAL" clId="{F4AAAA8C-1CB2-214C-996A-F15BCA6CB64E}"/>
-    <pc:docChg chg="undo custSel addSld delSld modSld">
-      <pc:chgData name="Riccardo Berta" userId="c8694f89-bba4-4576-b0a8-456619ca5a8c" providerId="ADAL" clId="{F4AAAA8C-1CB2-214C-996A-F15BCA6CB64E}" dt="2022-07-29T16:21:50.628" v="2975" actId="1076"/>
-      <pc:docMkLst>
-        <pc:docMk/>
-      </pc:docMkLst>
-      <pc:sldChg chg="modSp mod">
-        <pc:chgData name="Riccardo Berta" userId="c8694f89-bba4-4576-b0a8-456619ca5a8c" providerId="ADAL" clId="{F4AAAA8C-1CB2-214C-996A-F15BCA6CB64E}" dt="2022-07-27T13:37:29.445" v="2" actId="20577"/>
-        <pc:sldMkLst>
-          <pc:docMk/>
-          <pc:sldMk cId="0" sldId="256"/>
-        </pc:sldMkLst>
-      </pc:sldChg>
-      <pc:sldChg chg="addSp modSp mod">
-        <pc:chgData name="Riccardo Berta" userId="c8694f89-bba4-4576-b0a8-456619ca5a8c" providerId="ADAL" clId="{F4AAAA8C-1CB2-214C-996A-F15BCA6CB64E}" dt="2022-07-27T13:43:23.760" v="162" actId="20577"/>
-        <pc:sldMkLst>
-          <pc:docMk/>
-          <pc:sldMk cId="0" sldId="257"/>
-        </pc:sldMkLst>
-      </pc:sldChg>
-      <pc:sldChg chg="modSp del">
-        <pc:chgData name="Riccardo Berta" userId="c8694f89-bba4-4576-b0a8-456619ca5a8c" providerId="ADAL" clId="{F4AAAA8C-1CB2-214C-996A-F15BCA6CB64E}" dt="2022-07-27T13:43:43.714" v="164" actId="2696"/>
-        <pc:sldMkLst>
-          <pc:docMk/>
-          <pc:sldMk cId="1899110855" sldId="258"/>
-        </pc:sldMkLst>
-      </pc:sldChg>
-      <pc:sldChg chg="addSp delSp modSp mod">
-        <pc:chgData name="Riccardo Berta" userId="c8694f89-bba4-4576-b0a8-456619ca5a8c" providerId="ADAL" clId="{F4AAAA8C-1CB2-214C-996A-F15BCA6CB64E}" dt="2022-07-29T16:13:43.411" v="2890" actId="20577"/>
-        <pc:sldMkLst>
-          <pc:docMk/>
-          <pc:sldMk cId="3018556184" sldId="259"/>
-        </pc:sldMkLst>
-      </pc:sldChg>
-      <pc:sldChg chg="del">
-        <pc:chgData name="Riccardo Berta" userId="c8694f89-bba4-4576-b0a8-456619ca5a8c" providerId="ADAL" clId="{F4AAAA8C-1CB2-214C-996A-F15BCA6CB64E}" dt="2022-07-27T13:43:45.045" v="165" actId="2696"/>
-        <pc:sldMkLst>
-          <pc:docMk/>
-          <pc:sldMk cId="1104208334" sldId="260"/>
-        </pc:sldMkLst>
-      </pc:sldChg>
-      <pc:sldChg chg="addSp delSp modSp add mod">
-        <pc:chgData name="Riccardo Berta" userId="c8694f89-bba4-4576-b0a8-456619ca5a8c" providerId="ADAL" clId="{F4AAAA8C-1CB2-214C-996A-F15BCA6CB64E}" dt="2022-07-28T05:47:21.216" v="337" actId="1076"/>
-        <pc:sldMkLst>
-          <pc:docMk/>
-          <pc:sldMk cId="2119751735" sldId="260"/>
-        </pc:sldMkLst>
-      </pc:sldChg>
-      <pc:sldChg chg="del">
-        <pc:chgData name="Riccardo Berta" userId="c8694f89-bba4-4576-b0a8-456619ca5a8c" providerId="ADAL" clId="{F4AAAA8C-1CB2-214C-996A-F15BCA6CB64E}" dt="2022-07-27T13:43:46.058" v="166" actId="2696"/>
-        <pc:sldMkLst>
-          <pc:docMk/>
-          <pc:sldMk cId="1290395919" sldId="261"/>
-        </pc:sldMkLst>
-      </pc:sldChg>
-      <pc:sldChg chg="delSp modSp add mod">
-        <pc:chgData name="Riccardo Berta" userId="c8694f89-bba4-4576-b0a8-456619ca5a8c" providerId="ADAL" clId="{F4AAAA8C-1CB2-214C-996A-F15BCA6CB64E}" dt="2022-07-28T06:08:36.900" v="979" actId="20577"/>
-        <pc:sldMkLst>
-          <pc:docMk/>
-          <pc:sldMk cId="2389937581" sldId="261"/>
-        </pc:sldMkLst>
-      </pc:sldChg>
-      <pc:sldChg chg="addSp delSp modSp add mod">
-        <pc:chgData name="Riccardo Berta" userId="c8694f89-bba4-4576-b0a8-456619ca5a8c" providerId="ADAL" clId="{F4AAAA8C-1CB2-214C-996A-F15BCA6CB64E}" dt="2022-07-28T06:20:33.799" v="1324" actId="58"/>
-        <pc:sldMkLst>
-          <pc:docMk/>
-          <pc:sldMk cId="1270389364" sldId="262"/>
-        </pc:sldMkLst>
-      </pc:sldChg>
-      <pc:sldChg chg="del">
-        <pc:chgData name="Riccardo Berta" userId="c8694f89-bba4-4576-b0a8-456619ca5a8c" providerId="ADAL" clId="{F4AAAA8C-1CB2-214C-996A-F15BCA6CB64E}" dt="2022-07-27T13:43:47.251" v="167" actId="2696"/>
-        <pc:sldMkLst>
-          <pc:docMk/>
-          <pc:sldMk cId="4130549615" sldId="262"/>
-        </pc:sldMkLst>
-      </pc:sldChg>
-      <pc:sldChg chg="modSp add mod">
-        <pc:chgData name="Riccardo Berta" userId="c8694f89-bba4-4576-b0a8-456619ca5a8c" providerId="ADAL" clId="{F4AAAA8C-1CB2-214C-996A-F15BCA6CB64E}" dt="2022-07-29T07:18:15.970" v="2126" actId="1076"/>
-        <pc:sldMkLst>
-          <pc:docMk/>
-          <pc:sldMk cId="2644872656" sldId="263"/>
-        </pc:sldMkLst>
-      </pc:sldChg>
-      <pc:sldChg chg="del">
-        <pc:chgData name="Riccardo Berta" userId="c8694f89-bba4-4576-b0a8-456619ca5a8c" providerId="ADAL" clId="{F4AAAA8C-1CB2-214C-996A-F15BCA6CB64E}" dt="2022-07-27T13:43:48.139" v="168" actId="2696"/>
-        <pc:sldMkLst>
-          <pc:docMk/>
-          <pc:sldMk cId="3102138681" sldId="263"/>
-        </pc:sldMkLst>
-      </pc:sldChg>
-      <pc:sldChg chg="modSp add mod">
-        <pc:chgData name="Riccardo Berta" userId="c8694f89-bba4-4576-b0a8-456619ca5a8c" providerId="ADAL" clId="{F4AAAA8C-1CB2-214C-996A-F15BCA6CB64E}" dt="2022-07-28T13:59:43.403" v="1794" actId="20577"/>
-        <pc:sldMkLst>
-          <pc:docMk/>
-          <pc:sldMk cId="1681389695" sldId="264"/>
-        </pc:sldMkLst>
-      </pc:sldChg>
-      <pc:sldChg chg="del">
-        <pc:chgData name="Riccardo Berta" userId="c8694f89-bba4-4576-b0a8-456619ca5a8c" providerId="ADAL" clId="{F4AAAA8C-1CB2-214C-996A-F15BCA6CB64E}" dt="2022-07-27T13:43:49.652" v="169" actId="2696"/>
-        <pc:sldMkLst>
-          <pc:docMk/>
-          <pc:sldMk cId="2113557187" sldId="264"/>
-        </pc:sldMkLst>
-      </pc:sldChg>
-      <pc:sldChg chg="del">
-        <pc:chgData name="Riccardo Berta" userId="c8694f89-bba4-4576-b0a8-456619ca5a8c" providerId="ADAL" clId="{F4AAAA8C-1CB2-214C-996A-F15BCA6CB64E}" dt="2022-07-27T13:43:57.658" v="170" actId="2696"/>
-        <pc:sldMkLst>
-          <pc:docMk/>
-          <pc:sldMk cId="2045385232" sldId="265"/>
-        </pc:sldMkLst>
-      </pc:sldChg>
-      <pc:sldChg chg="addSp modSp add mod">
-        <pc:chgData name="Riccardo Berta" userId="c8694f89-bba4-4576-b0a8-456619ca5a8c" providerId="ADAL" clId="{F4AAAA8C-1CB2-214C-996A-F15BCA6CB64E}" dt="2022-07-29T07:15:19.612" v="2059" actId="1037"/>
-        <pc:sldMkLst>
-          <pc:docMk/>
-          <pc:sldMk cId="2862573505" sldId="265"/>
-        </pc:sldMkLst>
-      </pc:sldChg>
-      <pc:sldChg chg="modSp add mod">
-        <pc:chgData name="Riccardo Berta" userId="c8694f89-bba4-4576-b0a8-456619ca5a8c" providerId="ADAL" clId="{F4AAAA8C-1CB2-214C-996A-F15BCA6CB64E}" dt="2022-07-29T15:42:16.243" v="2364" actId="404"/>
-        <pc:sldMkLst>
-          <pc:docMk/>
-          <pc:sldMk cId="4181844165" sldId="266"/>
-        </pc:sldMkLst>
-      </pc:sldChg>
-      <pc:sldChg chg="addSp delSp modSp add mod">
-        <pc:chgData name="Riccardo Berta" userId="c8694f89-bba4-4576-b0a8-456619ca5a8c" providerId="ADAL" clId="{F4AAAA8C-1CB2-214C-996A-F15BCA6CB64E}" dt="2022-07-29T16:21:50.628" v="2975" actId="1076"/>
-        <pc:sldMkLst>
-          <pc:docMk/>
-          <pc:sldMk cId="216455838" sldId="267"/>
-        </pc:sldMkLst>
-      </pc:sldChg>
-      <pc:sldChg chg="modSp add mod">
-        <pc:chgData name="Riccardo Berta" userId="c8694f89-bba4-4576-b0a8-456619ca5a8c" providerId="ADAL" clId="{F4AAAA8C-1CB2-214C-996A-F15BCA6CB64E}" dt="2022-07-29T16:13:07.544" v="2873" actId="20577"/>
-        <pc:sldMkLst>
-          <pc:docMk/>
-          <pc:sldMk cId="925286286" sldId="268"/>
-        </pc:sldMkLst>
-      </pc:sldChg>
-      <pc:sldChg chg="addSp modSp add mod">
-        <pc:chgData name="Riccardo Berta" userId="c8694f89-bba4-4576-b0a8-456619ca5a8c" providerId="ADAL" clId="{F4AAAA8C-1CB2-214C-996A-F15BCA6CB64E}" dt="2022-07-29T16:20:35.039" v="2951" actId="962"/>
-        <pc:sldMkLst>
-          <pc:docMk/>
-          <pc:sldMk cId="3471997037" sldId="269"/>
-        </pc:sldMkLst>
-      </pc:sldChg>
-      <pc:sldChg chg="add">
-        <pc:chgData name="Riccardo Berta" userId="c8694f89-bba4-4576-b0a8-456619ca5a8c" providerId="ADAL" clId="{F4AAAA8C-1CB2-214C-996A-F15BCA6CB64E}" dt="2022-07-28T14:01:20.148" v="1808"/>
-        <pc:sldMkLst>
-          <pc:docMk/>
-          <pc:sldMk cId="3130917410" sldId="270"/>
-        </pc:sldMkLst>
-      </pc:sldChg>
-      <pc:sldChg chg="add">
-        <pc:chgData name="Riccardo Berta" userId="c8694f89-bba4-4576-b0a8-456619ca5a8c" providerId="ADAL" clId="{F4AAAA8C-1CB2-214C-996A-F15BCA6CB64E}" dt="2022-07-28T14:01:20.483" v="1809"/>
-        <pc:sldMkLst>
-          <pc:docMk/>
-          <pc:sldMk cId="2266699268" sldId="271"/>
-        </pc:sldMkLst>
-      </pc:sldChg>
-    </pc:docChg>
-  </pc:docChgLst>
-  <pc:docChgLst>
-    <pc:chgData name="Riccardo Berta" userId="c8694f89-bba4-4576-b0a8-456619ca5a8c" providerId="ADAL" clId="{A8290FA7-622A-D149-8650-9DF3F18680D5}"/>
-    <pc:docChg chg="undo redo custSel addSld delSld modSld sldOrd modMainMaster">
-      <pc:chgData name="Riccardo Berta" userId="c8694f89-bba4-4576-b0a8-456619ca5a8c" providerId="ADAL" clId="{A8290FA7-622A-D149-8650-9DF3F18680D5}" dt="2022-07-27T13:36:04.688" v="2998"/>
-      <pc:docMkLst>
-        <pc:docMk/>
-      </pc:docMkLst>
-      <pc:sldChg chg="delSp modSp mod">
-        <pc:chgData name="Riccardo Berta" userId="c8694f89-bba4-4576-b0a8-456619ca5a8c" providerId="ADAL" clId="{A8290FA7-622A-D149-8650-9DF3F18680D5}" dt="2022-07-27T13:35:14.530" v="2993" actId="20577"/>
-        <pc:sldMkLst>
-          <pc:docMk/>
-          <pc:sldMk cId="0" sldId="256"/>
-        </pc:sldMkLst>
-      </pc:sldChg>
-      <pc:sldChg chg="delSp modSp mod">
-        <pc:chgData name="Riccardo Berta" userId="c8694f89-bba4-4576-b0a8-456619ca5a8c" providerId="ADAL" clId="{A8290FA7-622A-D149-8650-9DF3F18680D5}" dt="2022-07-27T08:46:23.569" v="1166" actId="948"/>
-        <pc:sldMkLst>
-          <pc:docMk/>
-          <pc:sldMk cId="0" sldId="257"/>
-        </pc:sldMkLst>
-      </pc:sldChg>
-      <pc:sldChg chg="addSp modSp new mod modNotes">
-        <pc:chgData name="Riccardo Berta" userId="c8694f89-bba4-4576-b0a8-456619ca5a8c" providerId="ADAL" clId="{A8290FA7-622A-D149-8650-9DF3F18680D5}" dt="2022-07-27T08:52:46.755" v="1313" actId="113"/>
-        <pc:sldMkLst>
-          <pc:docMk/>
-          <pc:sldMk cId="1899110855" sldId="258"/>
-        </pc:sldMkLst>
-      </pc:sldChg>
-      <pc:sldChg chg="new del">
-        <pc:chgData name="Riccardo Berta" userId="c8694f89-bba4-4576-b0a8-456619ca5a8c" providerId="ADAL" clId="{A8290FA7-622A-D149-8650-9DF3F18680D5}" dt="2022-07-27T07:48:28.832" v="223" actId="2696"/>
-        <pc:sldMkLst>
-          <pc:docMk/>
-          <pc:sldMk cId="182339981" sldId="259"/>
-        </pc:sldMkLst>
-      </pc:sldChg>
-      <pc:sldChg chg="del">
-        <pc:chgData name="Riccardo Berta" userId="c8694f89-bba4-4576-b0a8-456619ca5a8c" providerId="ADAL" clId="{A8290FA7-622A-D149-8650-9DF3F18680D5}" dt="2022-07-18T11:39:57.790" v="23" actId="2696"/>
-        <pc:sldMkLst>
-          <pc:docMk/>
-          <pc:sldMk cId="3018556184" sldId="259"/>
-        </pc:sldMkLst>
-      </pc:sldChg>
-      <pc:sldChg chg="addSp modSp new mod">
-        <pc:chgData name="Riccardo Berta" userId="c8694f89-bba4-4576-b0a8-456619ca5a8c" providerId="ADAL" clId="{A8290FA7-622A-D149-8650-9DF3F18680D5}" dt="2022-07-27T08:48:59.292" v="1210" actId="1076"/>
-        <pc:sldMkLst>
-          <pc:docMk/>
-          <pc:sldMk cId="1104208334" sldId="260"/>
-        </pc:sldMkLst>
-      </pc:sldChg>
-      <pc:sldChg chg="del">
-        <pc:chgData name="Riccardo Berta" userId="c8694f89-bba4-4576-b0a8-456619ca5a8c" providerId="ADAL" clId="{A8290FA7-622A-D149-8650-9DF3F18680D5}" dt="2022-07-18T11:39:58.142" v="25" actId="2696"/>
-        <pc:sldMkLst>
-          <pc:docMk/>
-          <pc:sldMk cId="1290395919" sldId="261"/>
-        </pc:sldMkLst>
-      </pc:sldChg>
-      <pc:sldChg chg="new del">
-        <pc:chgData name="Riccardo Berta" userId="c8694f89-bba4-4576-b0a8-456619ca5a8c" providerId="ADAL" clId="{A8290FA7-622A-D149-8650-9DF3F18680D5}" dt="2022-07-27T10:14:34.151" v="1776" actId="2696"/>
-        <pc:sldMkLst>
-          <pc:docMk/>
-          <pc:sldMk cId="1228403239" sldId="262"/>
-        </pc:sldMkLst>
-      </pc:sldChg>
-      <pc:sldChg chg="addSp modSp add mod">
-        <pc:chgData name="Riccardo Berta" userId="c8694f89-bba4-4576-b0a8-456619ca5a8c" providerId="ADAL" clId="{A8290FA7-622A-D149-8650-9DF3F18680D5}" dt="2022-07-27T10:42:13.820" v="2230" actId="113"/>
-        <pc:sldMkLst>
-          <pc:docMk/>
-          <pc:sldMk cId="4130549615" sldId="262"/>
-        </pc:sldMkLst>
-      </pc:sldChg>
-      <pc:sldChg chg="new del">
-        <pc:chgData name="Riccardo Berta" userId="c8694f89-bba4-4576-b0a8-456619ca5a8c" providerId="ADAL" clId="{A8290FA7-622A-D149-8650-9DF3F18680D5}" dt="2022-07-27T10:14:17.648" v="1770" actId="2696"/>
-        <pc:sldMkLst>
-          <pc:docMk/>
-          <pc:sldMk cId="4179454221" sldId="262"/>
-        </pc:sldMkLst>
-      </pc:sldChg>
-      <pc:sldChg chg="addSp delSp modSp new del mod">
-        <pc:chgData name="Riccardo Berta" userId="c8694f89-bba4-4576-b0a8-456619ca5a8c" providerId="ADAL" clId="{A8290FA7-622A-D149-8650-9DF3F18680D5}" dt="2022-07-27T10:14:36.007" v="1777" actId="2696"/>
-        <pc:sldMkLst>
-          <pc:docMk/>
-          <pc:sldMk cId="2702540954" sldId="263"/>
-        </pc:sldMkLst>
-      </pc:sldChg>
-      <pc:sldChg chg="del">
-        <pc:chgData name="Riccardo Berta" userId="c8694f89-bba4-4576-b0a8-456619ca5a8c" providerId="ADAL" clId="{A8290FA7-622A-D149-8650-9DF3F18680D5}" dt="2022-07-18T11:39:58.451" v="27" actId="2696"/>
-        <pc:sldMkLst>
-          <pc:docMk/>
-          <pc:sldMk cId="3102138681" sldId="263"/>
-        </pc:sldMkLst>
-      </pc:sldChg>
-      <pc:sldChg chg="addSp modSp add del mod">
-        <pc:chgData name="Riccardo Berta" userId="c8694f89-bba4-4576-b0a8-456619ca5a8c" providerId="ADAL" clId="{A8290FA7-622A-D149-8650-9DF3F18680D5}" dt="2022-07-27T10:42:20.886" v="2231" actId="2696"/>
-        <pc:sldMkLst>
-          <pc:docMk/>
-          <pc:sldMk cId="3911169705" sldId="263"/>
-        </pc:sldMkLst>
-      </pc:sldChg>
-      <pc:sldChg chg="del">
-        <pc:chgData name="Riccardo Berta" userId="c8694f89-bba4-4576-b0a8-456619ca5a8c" providerId="ADAL" clId="{A8290FA7-622A-D149-8650-9DF3F18680D5}" dt="2022-07-18T11:39:58.616" v="28" actId="2696"/>
-        <pc:sldMkLst>
-          <pc:docMk/>
-          <pc:sldMk cId="2113557187" sldId="264"/>
-        </pc:sldMkLst>
-      </pc:sldChg>
-      <pc:sldChg chg="del">
-        <pc:chgData name="Riccardo Berta" userId="c8694f89-bba4-4576-b0a8-456619ca5a8c" providerId="ADAL" clId="{A8290FA7-622A-D149-8650-9DF3F18680D5}" dt="2022-07-18T11:39:58.749" v="29" actId="2696"/>
-        <pc:sldMkLst>
-          <pc:docMk/>
-          <pc:sldMk cId="2045385232" sldId="265"/>
-        </pc:sldMkLst>
-      </pc:sldChg>
-      <pc:sldChg chg="del">
-        <pc:chgData name="Riccardo Berta" userId="c8694f89-bba4-4576-b0a8-456619ca5a8c" providerId="ADAL" clId="{A8290FA7-622A-D149-8650-9DF3F18680D5}" dt="2022-07-18T11:39:58.869" v="30" actId="2696"/>
-        <pc:sldMkLst>
-          <pc:docMk/>
-          <pc:sldMk cId="4181844165" sldId="266"/>
-        </pc:sldMkLst>
-      </pc:sldChg>
-      <pc:sldChg chg="del">
-        <pc:chgData name="Riccardo Berta" userId="c8694f89-bba4-4576-b0a8-456619ca5a8c" providerId="ADAL" clId="{A8290FA7-622A-D149-8650-9DF3F18680D5}" dt="2022-07-18T11:39:59.035" v="31" actId="2696"/>
-        <pc:sldMkLst>
-          <pc:docMk/>
-          <pc:sldMk cId="216455838" sldId="267"/>
-        </pc:sldMkLst>
-      </pc:sldChg>
-      <pc:sldChg chg="del">
-        <pc:chgData name="Riccardo Berta" userId="c8694f89-bba4-4576-b0a8-456619ca5a8c" providerId="ADAL" clId="{A8290FA7-622A-D149-8650-9DF3F18680D5}" dt="2022-07-18T11:39:59.202" v="32" actId="2696"/>
-        <pc:sldMkLst>
-          <pc:docMk/>
-          <pc:sldMk cId="3471997037" sldId="269"/>
-        </pc:sldMkLst>
-      </pc:sldChg>
-      <pc:sldChg chg="del">
-        <pc:chgData name="Riccardo Berta" userId="c8694f89-bba4-4576-b0a8-456619ca5a8c" providerId="ADAL" clId="{A8290FA7-622A-D149-8650-9DF3F18680D5}" dt="2022-07-18T11:39:59.363" v="33" actId="2696"/>
-        <pc:sldMkLst>
-          <pc:docMk/>
-          <pc:sldMk cId="3130917410" sldId="270"/>
-        </pc:sldMkLst>
-      </pc:sldChg>
-      <pc:sldChg chg="del">
-        <pc:chgData name="Riccardo Berta" userId="c8694f89-bba4-4576-b0a8-456619ca5a8c" providerId="ADAL" clId="{A8290FA7-622A-D149-8650-9DF3F18680D5}" dt="2022-07-18T11:39:59.502" v="34" actId="2696"/>
-        <pc:sldMkLst>
-          <pc:docMk/>
-          <pc:sldMk cId="2266699268" sldId="271"/>
-        </pc:sldMkLst>
-      </pc:sldChg>
-      <pc:sldChg chg="del">
-        <pc:chgData name="Riccardo Berta" userId="c8694f89-bba4-4576-b0a8-456619ca5a8c" providerId="ADAL" clId="{A8290FA7-622A-D149-8650-9DF3F18680D5}" dt="2022-07-18T11:40:00.091" v="38" actId="2696"/>
-        <pc:sldMkLst>
-          <pc:docMk/>
-          <pc:sldMk cId="993270251" sldId="272"/>
-        </pc:sldMkLst>
-      </pc:sldChg>
-      <pc:sldChg chg="del">
-        <pc:chgData name="Riccardo Berta" userId="c8694f89-bba4-4576-b0a8-456619ca5a8c" providerId="ADAL" clId="{A8290FA7-622A-D149-8650-9DF3F18680D5}" dt="2022-07-18T11:39:59.623" v="35" actId="2696"/>
-        <pc:sldMkLst>
-          <pc:docMk/>
-          <pc:sldMk cId="3843819371" sldId="273"/>
-        </pc:sldMkLst>
-      </pc:sldChg>
-      <pc:sldChg chg="del">
-        <pc:chgData name="Riccardo Berta" userId="c8694f89-bba4-4576-b0a8-456619ca5a8c" providerId="ADAL" clId="{A8290FA7-622A-D149-8650-9DF3F18680D5}" dt="2022-07-18T11:39:59.806" v="36" actId="2696"/>
-        <pc:sldMkLst>
-          <pc:docMk/>
-          <pc:sldMk cId="3084049364" sldId="274"/>
-        </pc:sldMkLst>
-      </pc:sldChg>
-      <pc:sldChg chg="del">
-        <pc:chgData name="Riccardo Berta" userId="c8694f89-bba4-4576-b0a8-456619ca5a8c" providerId="ADAL" clId="{A8290FA7-622A-D149-8650-9DF3F18680D5}" dt="2022-07-18T11:39:59.937" v="37" actId="2696"/>
-        <pc:sldMkLst>
-          <pc:docMk/>
-          <pc:sldMk cId="284781631" sldId="275"/>
-        </pc:sldMkLst>
-      </pc:sldChg>
-      <pc:sldMasterChg chg="modSp mod delSldLayout modSldLayout">
-        <pc:chgData name="Riccardo Berta" userId="c8694f89-bba4-4576-b0a8-456619ca5a8c" providerId="ADAL" clId="{A8290FA7-622A-D149-8650-9DF3F18680D5}" dt="2022-07-27T08:45:00.853" v="1135" actId="20577"/>
-        <pc:sldMasterMkLst>
-          <pc:docMk/>
-          <pc:sldMasterMk cId="0" sldId="2147483659"/>
-        </pc:sldMasterMkLst>
-        <pc:sldLayoutChg chg="del">
-          <pc:chgData name="Riccardo Berta" userId="c8694f89-bba4-4576-b0a8-456619ca5a8c" providerId="ADAL" clId="{A8290FA7-622A-D149-8650-9DF3F18680D5}" dt="2022-07-27T07:48:28.832" v="223" actId="2696"/>
-          <pc:sldLayoutMkLst>
+            <pc:sldMk cId="0" sldId="257"/>
+            <ac:spMk id="84" creationId="{00000000-0000-0000-0000-000000000000}"/>
+          </ac:spMkLst>
+        </pc:spChg>
+        <pc:picChg chg="add mod">
+          <ac:chgData name="Riccardo Berta" userId="c8694f89-bba4-4576-b0a8-456619ca5a8c" providerId="ADAL" clId="{FDDBFC5A-5EA9-5330-BEB8-433D7E3B4C4E}" dt="2026-09-04T12:35:37.158" v="75" actId="1076"/>
+          <ac:picMkLst>
             <pc:docMk/>
-            <pc:sldMasterMk cId="0" sldId="2147483659"/>
-            <pc:sldLayoutMk cId="0" sldId="2147483649"/>
-          </pc:sldLayoutMkLst>
-        </pc:sldLayoutChg>
-        <pc:sldLayoutChg chg="delSp">
-          <pc:chgData name="Riccardo Berta" userId="c8694f89-bba4-4576-b0a8-456619ca5a8c" providerId="ADAL" clId="{A8290FA7-622A-D149-8650-9DF3F18680D5}" dt="2022-07-27T08:44:23.725" v="1124"/>
-          <pc:sldLayoutMkLst>
-            <pc:docMk/>
-            <pc:sldMasterMk cId="0" sldId="2147483659"/>
-            <pc:sldLayoutMk cId="0" sldId="2147483650"/>
-          </pc:sldLayoutMkLst>
-        </pc:sldLayoutChg>
-      </pc:sldMasterChg>
-    </pc:docChg>
-  </pc:docChgLst>
-  <pc:docChgLst>
-    <pc:chgData name="Riccardo Berta" userId="c8694f89-bba4-4576-b0a8-456619ca5a8c" providerId="ADAL" clId="{285D91C1-4BF4-0841-A283-B28F698AE366}"/>
-    <pc:docChg chg="custSel addSld modSld">
-      <pc:chgData name="Riccardo Berta" userId="c8694f89-bba4-4576-b0a8-456619ca5a8c" providerId="ADAL" clId="{285D91C1-4BF4-0841-A283-B28F698AE366}" dt="2022-08-26T17:01:29.210" v="222" actId="20577"/>
-      <pc:docMkLst>
-        <pc:docMk/>
-      </pc:docMkLst>
-      <pc:sldChg chg="addSp delSp modSp add mod">
-        <pc:chgData name="Riccardo Berta" userId="c8694f89-bba4-4576-b0a8-456619ca5a8c" providerId="ADAL" clId="{285D91C1-4BF4-0841-A283-B28F698AE366}" dt="2022-08-26T17:01:29.210" v="222" actId="20577"/>
-        <pc:sldMkLst>
-          <pc:docMk/>
-          <pc:sldMk cId="1388305878" sldId="277"/>
-        </pc:sldMkLst>
-      </pc:sldChg>
-      <pc:sldChg chg="addSp delSp modSp add mod">
-        <pc:chgData name="Riccardo Berta" userId="c8694f89-bba4-4576-b0a8-456619ca5a8c" providerId="ADAL" clId="{285D91C1-4BF4-0841-A283-B28F698AE366}" dt="2022-08-26T17:01:19.085" v="220" actId="1076"/>
-        <pc:sldMkLst>
-          <pc:docMk/>
-          <pc:sldMk cId="2276488042" sldId="278"/>
-        </pc:sldMkLst>
-      </pc:sldChg>
-    </pc:docChg>
-  </pc:docChgLst>
-  <pc:docChgLst>
-    <pc:chgData name="Riccardo Berta" userId="c8694f89-bba4-4576-b0a8-456619ca5a8c" providerId="ADAL" clId="{58424B7E-67A2-E24B-9516-C248AFA19009}"/>
-    <pc:docChg chg="undo custSel addSld delSld modSld sldOrd modMainMaster">
-      <pc:chgData name="Riccardo Berta" userId="c8694f89-bba4-4576-b0a8-456619ca5a8c" providerId="ADAL" clId="{58424B7E-67A2-E24B-9516-C248AFA19009}" dt="2022-08-30T09:41:00.751" v="1457" actId="20577"/>
-      <pc:docMkLst>
-        <pc:docMk/>
-      </pc:docMkLst>
-      <pc:sldChg chg="modSp mod">
-        <pc:chgData name="Riccardo Berta" userId="c8694f89-bba4-4576-b0a8-456619ca5a8c" providerId="ADAL" clId="{58424B7E-67A2-E24B-9516-C248AFA19009}" dt="2022-08-30T09:38:38.114" v="1432" actId="790"/>
-        <pc:sldMkLst>
-          <pc:docMk/>
-          <pc:sldMk cId="0" sldId="256"/>
-        </pc:sldMkLst>
-      </pc:sldChg>
-      <pc:sldChg chg="addSp modSp mod">
-        <pc:chgData name="Riccardo Berta" userId="c8694f89-bba4-4576-b0a8-456619ca5a8c" providerId="ADAL" clId="{58424B7E-67A2-E24B-9516-C248AFA19009}" dt="2022-08-30T09:37:52.468" v="1397" actId="20577"/>
-        <pc:sldMkLst>
-          <pc:docMk/>
-          <pc:sldMk cId="0" sldId="257"/>
-        </pc:sldMkLst>
-      </pc:sldChg>
-      <pc:sldChg chg="modSp mod">
-        <pc:chgData name="Riccardo Berta" userId="c8694f89-bba4-4576-b0a8-456619ca5a8c" providerId="ADAL" clId="{58424B7E-67A2-E24B-9516-C248AFA19009}" dt="2022-08-30T09:41:00.751" v="1457" actId="20577"/>
-        <pc:sldMkLst>
-          <pc:docMk/>
-          <pc:sldMk cId="3018556184" sldId="259"/>
-        </pc:sldMkLst>
-      </pc:sldChg>
-      <pc:sldChg chg="del">
-        <pc:chgData name="Riccardo Berta" userId="c8694f89-bba4-4576-b0a8-456619ca5a8c" providerId="ADAL" clId="{58424B7E-67A2-E24B-9516-C248AFA19009}" dt="2022-08-30T08:44:09.932" v="12" actId="2696"/>
-        <pc:sldMkLst>
-          <pc:docMk/>
-          <pc:sldMk cId="1066709261" sldId="260"/>
-        </pc:sldMkLst>
-      </pc:sldChg>
-      <pc:sldChg chg="addSp modSp add mod">
-        <pc:chgData name="Riccardo Berta" userId="c8694f89-bba4-4576-b0a8-456619ca5a8c" providerId="ADAL" clId="{58424B7E-67A2-E24B-9516-C248AFA19009}" dt="2022-08-30T09:38:04.406" v="1411" actId="20577"/>
-        <pc:sldMkLst>
-          <pc:docMk/>
-          <pc:sldMk cId="3692252167" sldId="260"/>
-        </pc:sldMkLst>
-      </pc:sldChg>
-      <pc:sldChg chg="addSp modSp add mod">
-        <pc:chgData name="Riccardo Berta" userId="c8694f89-bba4-4576-b0a8-456619ca5a8c" providerId="ADAL" clId="{58424B7E-67A2-E24B-9516-C248AFA19009}" dt="2022-08-30T09:35:29.211" v="1307" actId="21"/>
-        <pc:sldMkLst>
-          <pc:docMk/>
-          <pc:sldMk cId="846979211" sldId="261"/>
-        </pc:sldMkLst>
-      </pc:sldChg>
-      <pc:sldChg chg="modSp add mod">
-        <pc:chgData name="Riccardo Berta" userId="c8694f89-bba4-4576-b0a8-456619ca5a8c" providerId="ADAL" clId="{58424B7E-67A2-E24B-9516-C248AFA19009}" dt="2022-08-30T09:19:27.119" v="830" actId="20577"/>
-        <pc:sldMkLst>
-          <pc:docMk/>
-          <pc:sldMk cId="447929702" sldId="262"/>
-        </pc:sldMkLst>
-      </pc:sldChg>
-      <pc:sldChg chg="addSp modSp add mod ord">
-        <pc:chgData name="Riccardo Berta" userId="c8694f89-bba4-4576-b0a8-456619ca5a8c" providerId="ADAL" clId="{58424B7E-67A2-E24B-9516-C248AFA19009}" dt="2022-08-30T09:40:40.663" v="1434" actId="20578"/>
-        <pc:sldMkLst>
-          <pc:docMk/>
-          <pc:sldMk cId="11402927" sldId="263"/>
-        </pc:sldMkLst>
-      </pc:sldChg>
-      <pc:sldChg chg="del">
-        <pc:chgData name="Riccardo Berta" userId="c8694f89-bba4-4576-b0a8-456619ca5a8c" providerId="ADAL" clId="{58424B7E-67A2-E24B-9516-C248AFA19009}" dt="2022-08-30T08:44:10.781" v="14" actId="2696"/>
-        <pc:sldMkLst>
-          <pc:docMk/>
-          <pc:sldMk cId="2190566097" sldId="263"/>
-        </pc:sldMkLst>
-      </pc:sldChg>
-      <pc:sldChg chg="modSp add mod ord">
-        <pc:chgData name="Riccardo Berta" userId="c8694f89-bba4-4576-b0a8-456619ca5a8c" providerId="ADAL" clId="{58424B7E-67A2-E24B-9516-C248AFA19009}" dt="2022-08-30T09:40:38.066" v="1433" actId="20578"/>
-        <pc:sldMkLst>
-          <pc:docMk/>
-          <pc:sldMk cId="2794482370" sldId="264"/>
-        </pc:sldMkLst>
-      </pc:sldChg>
-      <pc:sldChg chg="del">
-        <pc:chgData name="Riccardo Berta" userId="c8694f89-bba4-4576-b0a8-456619ca5a8c" providerId="ADAL" clId="{58424B7E-67A2-E24B-9516-C248AFA19009}" dt="2022-08-30T08:44:11.185" v="15" actId="2696"/>
-        <pc:sldMkLst>
-          <pc:docMk/>
-          <pc:sldMk cId="3888810046" sldId="264"/>
-        </pc:sldMkLst>
-      </pc:sldChg>
-      <pc:sldChg chg="add del">
-        <pc:chgData name="Riccardo Berta" userId="c8694f89-bba4-4576-b0a8-456619ca5a8c" providerId="ADAL" clId="{58424B7E-67A2-E24B-9516-C248AFA19009}" dt="2022-08-30T09:40:43.113" v="1435" actId="2696"/>
-        <pc:sldMkLst>
-          <pc:docMk/>
-          <pc:sldMk cId="1840044115" sldId="265"/>
-        </pc:sldMkLst>
-      </pc:sldChg>
-      <pc:sldChg chg="del">
-        <pc:chgData name="Riccardo Berta" userId="c8694f89-bba4-4576-b0a8-456619ca5a8c" providerId="ADAL" clId="{58424B7E-67A2-E24B-9516-C248AFA19009}" dt="2022-08-30T08:44:10.392" v="13" actId="2696"/>
-        <pc:sldMkLst>
-          <pc:docMk/>
-          <pc:sldMk cId="2733657070" sldId="265"/>
-        </pc:sldMkLst>
-      </pc:sldChg>
-      <pc:sldChg chg="del">
-        <pc:chgData name="Riccardo Berta" userId="c8694f89-bba4-4576-b0a8-456619ca5a8c" providerId="ADAL" clId="{58424B7E-67A2-E24B-9516-C248AFA19009}" dt="2022-08-30T08:44:11.546" v="16" actId="2696"/>
-        <pc:sldMkLst>
-          <pc:docMk/>
-          <pc:sldMk cId="2836957529" sldId="266"/>
-        </pc:sldMkLst>
-      </pc:sldChg>
-      <pc:sldChg chg="add del">
-        <pc:chgData name="Riccardo Berta" userId="c8694f89-bba4-4576-b0a8-456619ca5a8c" providerId="ADAL" clId="{58424B7E-67A2-E24B-9516-C248AFA19009}" dt="2022-08-30T09:40:44.686" v="1436" actId="2696"/>
-        <pc:sldMkLst>
-          <pc:docMk/>
-          <pc:sldMk cId="3173063083" sldId="266"/>
-        </pc:sldMkLst>
-      </pc:sldChg>
-      <pc:sldChg chg="del">
-        <pc:chgData name="Riccardo Berta" userId="c8694f89-bba4-4576-b0a8-456619ca5a8c" providerId="ADAL" clId="{58424B7E-67A2-E24B-9516-C248AFA19009}" dt="2022-08-30T08:44:11.879" v="17" actId="2696"/>
-        <pc:sldMkLst>
-          <pc:docMk/>
-          <pc:sldMk cId="3519359877" sldId="267"/>
-        </pc:sldMkLst>
-      </pc:sldChg>
-      <pc:sldChg chg="add del">
-        <pc:chgData name="Riccardo Berta" userId="c8694f89-bba4-4576-b0a8-456619ca5a8c" providerId="ADAL" clId="{58424B7E-67A2-E24B-9516-C248AFA19009}" dt="2022-08-30T09:40:45.351" v="1437" actId="2696"/>
-        <pc:sldMkLst>
-          <pc:docMk/>
-          <pc:sldMk cId="4284808824" sldId="267"/>
-        </pc:sldMkLst>
-      </pc:sldChg>
-      <pc:sldChg chg="add del">
-        <pc:chgData name="Riccardo Berta" userId="c8694f89-bba4-4576-b0a8-456619ca5a8c" providerId="ADAL" clId="{58424B7E-67A2-E24B-9516-C248AFA19009}" dt="2022-08-30T09:40:46.386" v="1438" actId="2696"/>
-        <pc:sldMkLst>
-          <pc:docMk/>
-          <pc:sldMk cId="2262434218" sldId="268"/>
-        </pc:sldMkLst>
-      </pc:sldChg>
-      <pc:sldChg chg="del">
-        <pc:chgData name="Riccardo Berta" userId="c8694f89-bba4-4576-b0a8-456619ca5a8c" providerId="ADAL" clId="{58424B7E-67A2-E24B-9516-C248AFA19009}" dt="2022-08-30T08:44:12.296" v="18" actId="2696"/>
-        <pc:sldMkLst>
-          <pc:docMk/>
-          <pc:sldMk cId="3883776362" sldId="268"/>
-        </pc:sldMkLst>
-      </pc:sldChg>
-      <pc:sldChg chg="del">
-        <pc:chgData name="Riccardo Berta" userId="c8694f89-bba4-4576-b0a8-456619ca5a8c" providerId="ADAL" clId="{58424B7E-67A2-E24B-9516-C248AFA19009}" dt="2022-08-30T08:44:12.734" v="19" actId="2696"/>
-        <pc:sldMkLst>
-          <pc:docMk/>
-          <pc:sldMk cId="482081013" sldId="269"/>
-        </pc:sldMkLst>
-      </pc:sldChg>
-      <pc:sldChg chg="del">
-        <pc:chgData name="Riccardo Berta" userId="c8694f89-bba4-4576-b0a8-456619ca5a8c" providerId="ADAL" clId="{58424B7E-67A2-E24B-9516-C248AFA19009}" dt="2022-08-30T08:44:13.162" v="20" actId="2696"/>
-        <pc:sldMkLst>
-          <pc:docMk/>
-          <pc:sldMk cId="761532774" sldId="270"/>
-        </pc:sldMkLst>
-      </pc:sldChg>
-      <pc:sldChg chg="del">
-        <pc:chgData name="Riccardo Berta" userId="c8694f89-bba4-4576-b0a8-456619ca5a8c" providerId="ADAL" clId="{58424B7E-67A2-E24B-9516-C248AFA19009}" dt="2022-08-30T08:44:13.596" v="21" actId="2696"/>
-        <pc:sldMkLst>
-          <pc:docMk/>
-          <pc:sldMk cId="3967202540" sldId="271"/>
-        </pc:sldMkLst>
-      </pc:sldChg>
-      <pc:sldChg chg="del">
-        <pc:chgData name="Riccardo Berta" userId="c8694f89-bba4-4576-b0a8-456619ca5a8c" providerId="ADAL" clId="{58424B7E-67A2-E24B-9516-C248AFA19009}" dt="2022-08-30T08:44:14.037" v="22" actId="2696"/>
-        <pc:sldMkLst>
-          <pc:docMk/>
-          <pc:sldMk cId="2355894371" sldId="272"/>
-        </pc:sldMkLst>
-      </pc:sldChg>
-      <pc:sldChg chg="del">
-        <pc:chgData name="Riccardo Berta" userId="c8694f89-bba4-4576-b0a8-456619ca5a8c" providerId="ADAL" clId="{58424B7E-67A2-E24B-9516-C248AFA19009}" dt="2022-08-30T08:44:14.570" v="23" actId="2696"/>
-        <pc:sldMkLst>
-          <pc:docMk/>
-          <pc:sldMk cId="3843819371" sldId="273"/>
-        </pc:sldMkLst>
-      </pc:sldChg>
-      <pc:sldChg chg="del">
-        <pc:chgData name="Riccardo Berta" userId="c8694f89-bba4-4576-b0a8-456619ca5a8c" providerId="ADAL" clId="{58424B7E-67A2-E24B-9516-C248AFA19009}" dt="2022-08-30T08:44:15.613" v="24" actId="2696"/>
-        <pc:sldMkLst>
-          <pc:docMk/>
-          <pc:sldMk cId="806177680" sldId="274"/>
-        </pc:sldMkLst>
-      </pc:sldChg>
-      <pc:sldChg chg="del">
-        <pc:chgData name="Riccardo Berta" userId="c8694f89-bba4-4576-b0a8-456619ca5a8c" providerId="ADAL" clId="{58424B7E-67A2-E24B-9516-C248AFA19009}" dt="2022-08-30T08:44:16.250" v="25" actId="2696"/>
-        <pc:sldMkLst>
-          <pc:docMk/>
-          <pc:sldMk cId="284781631" sldId="275"/>
-        </pc:sldMkLst>
-      </pc:sldChg>
-      <pc:sldChg chg="del">
-        <pc:chgData name="Riccardo Berta" userId="c8694f89-bba4-4576-b0a8-456619ca5a8c" providerId="ADAL" clId="{58424B7E-67A2-E24B-9516-C248AFA19009}" dt="2022-08-30T08:44:17.013" v="26" actId="2696"/>
-        <pc:sldMkLst>
-          <pc:docMk/>
-          <pc:sldMk cId="4125292156" sldId="276"/>
-        </pc:sldMkLst>
-      </pc:sldChg>
-      <pc:sldChg chg="del">
-        <pc:chgData name="Riccardo Berta" userId="c8694f89-bba4-4576-b0a8-456619ca5a8c" providerId="ADAL" clId="{58424B7E-67A2-E24B-9516-C248AFA19009}" dt="2022-08-30T08:44:17.602" v="27" actId="2696"/>
-        <pc:sldMkLst>
-          <pc:docMk/>
-          <pc:sldMk cId="1388305878" sldId="277"/>
-        </pc:sldMkLst>
-      </pc:sldChg>
-      <pc:sldChg chg="del">
-        <pc:chgData name="Riccardo Berta" userId="c8694f89-bba4-4576-b0a8-456619ca5a8c" providerId="ADAL" clId="{58424B7E-67A2-E24B-9516-C248AFA19009}" dt="2022-08-30T08:44:18.091" v="28" actId="2696"/>
-        <pc:sldMkLst>
-          <pc:docMk/>
-          <pc:sldMk cId="2276488042" sldId="278"/>
-        </pc:sldMkLst>
-      </pc:sldChg>
-      <pc:sldMasterChg chg="modSldLayout">
-        <pc:chgData name="Riccardo Berta" userId="c8694f89-bba4-4576-b0a8-456619ca5a8c" providerId="ADAL" clId="{58424B7E-67A2-E24B-9516-C248AFA19009}" dt="2022-08-30T08:51:17.059" v="152" actId="948"/>
-        <pc:sldMasterMkLst>
-          <pc:docMk/>
-          <pc:sldMasterMk cId="0" sldId="2147483659"/>
-        </pc:sldMasterMkLst>
-        <pc:sldLayoutChg chg="modSp mod">
-          <pc:chgData name="Riccardo Berta" userId="c8694f89-bba4-4576-b0a8-456619ca5a8c" providerId="ADAL" clId="{58424B7E-67A2-E24B-9516-C248AFA19009}" dt="2022-08-30T08:51:17.059" v="152" actId="948"/>
-          <pc:sldLayoutMkLst>
-            <pc:docMk/>
-            <pc:sldMasterMk cId="0" sldId="2147483659"/>
-            <pc:sldLayoutMk cId="0" sldId="2147483650"/>
-          </pc:sldLayoutMkLst>
-        </pc:sldLayoutChg>
-      </pc:sldMasterChg>
-    </pc:docChg>
-  </pc:docChgLst>
-  <pc:docChgLst>
-    <pc:chgData name="Riccardo Berta" userId="c8694f89-bba4-4576-b0a8-456619ca5a8c" providerId="ADAL" clId="{89457721-8AF9-BB44-BAF2-46F7B0D7D7E8}"/>
-    <pc:docChg chg="custSel addSld delSld modSld">
-      <pc:chgData name="Riccardo Berta" userId="c8694f89-bba4-4576-b0a8-456619ca5a8c" providerId="ADAL" clId="{89457721-8AF9-BB44-BAF2-46F7B0D7D7E8}" dt="2022-08-30T09:55:24.863" v="44" actId="20577"/>
-      <pc:docMkLst>
-        <pc:docMk/>
-      </pc:docMkLst>
-      <pc:sldChg chg="modSp mod">
-        <pc:chgData name="Riccardo Berta" userId="c8694f89-bba4-4576-b0a8-456619ca5a8c" providerId="ADAL" clId="{89457721-8AF9-BB44-BAF2-46F7B0D7D7E8}" dt="2022-08-30T09:54:06.379" v="7" actId="20577"/>
-        <pc:sldMkLst>
-          <pc:docMk/>
-          <pc:sldMk cId="0" sldId="256"/>
-        </pc:sldMkLst>
-      </pc:sldChg>
-      <pc:sldChg chg="delSp modSp mod">
-        <pc:chgData name="Riccardo Berta" userId="c8694f89-bba4-4576-b0a8-456619ca5a8c" providerId="ADAL" clId="{89457721-8AF9-BB44-BAF2-46F7B0D7D7E8}" dt="2022-08-30T09:54:23.221" v="18" actId="478"/>
-        <pc:sldMkLst>
-          <pc:docMk/>
-          <pc:sldMk cId="0" sldId="257"/>
-        </pc:sldMkLst>
-      </pc:sldChg>
-      <pc:sldChg chg="modSp mod">
-        <pc:chgData name="Riccardo Berta" userId="c8694f89-bba4-4576-b0a8-456619ca5a8c" providerId="ADAL" clId="{89457721-8AF9-BB44-BAF2-46F7B0D7D7E8}" dt="2022-08-30T09:54:11.362" v="10" actId="20577"/>
-        <pc:sldMkLst>
-          <pc:docMk/>
-          <pc:sldMk cId="3018556184" sldId="259"/>
-        </pc:sldMkLst>
-      </pc:sldChg>
-      <pc:sldChg chg="add">
-        <pc:chgData name="Riccardo Berta" userId="c8694f89-bba4-4576-b0a8-456619ca5a8c" providerId="ADAL" clId="{89457721-8AF9-BB44-BAF2-46F7B0D7D7E8}" dt="2022-08-30T09:54:31.238" v="24"/>
-        <pc:sldMkLst>
-          <pc:docMk/>
-          <pc:sldMk cId="3239712184" sldId="260"/>
-        </pc:sldMkLst>
-      </pc:sldChg>
-      <pc:sldChg chg="del">
-        <pc:chgData name="Riccardo Berta" userId="c8694f89-bba4-4576-b0a8-456619ca5a8c" providerId="ADAL" clId="{89457721-8AF9-BB44-BAF2-46F7B0D7D7E8}" dt="2022-08-30T09:54:26.068" v="19" actId="2696"/>
-        <pc:sldMkLst>
-          <pc:docMk/>
-          <pc:sldMk cId="3692252167" sldId="260"/>
-        </pc:sldMkLst>
-      </pc:sldChg>
-      <pc:sldChg chg="add">
-        <pc:chgData name="Riccardo Berta" userId="c8694f89-bba4-4576-b0a8-456619ca5a8c" providerId="ADAL" clId="{89457721-8AF9-BB44-BAF2-46F7B0D7D7E8}" dt="2022-08-30T09:54:32.176" v="25"/>
-        <pc:sldMkLst>
-          <pc:docMk/>
-          <pc:sldMk cId="723946338" sldId="261"/>
-        </pc:sldMkLst>
-      </pc:sldChg>
-      <pc:sldChg chg="del">
-        <pc:chgData name="Riccardo Berta" userId="c8694f89-bba4-4576-b0a8-456619ca5a8c" providerId="ADAL" clId="{89457721-8AF9-BB44-BAF2-46F7B0D7D7E8}" dt="2022-08-30T09:54:26.532" v="20" actId="2696"/>
-        <pc:sldMkLst>
-          <pc:docMk/>
-          <pc:sldMk cId="846979211" sldId="261"/>
-        </pc:sldMkLst>
-      </pc:sldChg>
-      <pc:sldChg chg="del">
-        <pc:chgData name="Riccardo Berta" userId="c8694f89-bba4-4576-b0a8-456619ca5a8c" providerId="ADAL" clId="{89457721-8AF9-BB44-BAF2-46F7B0D7D7E8}" dt="2022-08-30T09:54:26.938" v="21" actId="2696"/>
-        <pc:sldMkLst>
-          <pc:docMk/>
-          <pc:sldMk cId="447929702" sldId="262"/>
-        </pc:sldMkLst>
-      </pc:sldChg>
-      <pc:sldChg chg="add">
-        <pc:chgData name="Riccardo Berta" userId="c8694f89-bba4-4576-b0a8-456619ca5a8c" providerId="ADAL" clId="{89457721-8AF9-BB44-BAF2-46F7B0D7D7E8}" dt="2022-08-30T09:54:33.167" v="26"/>
-        <pc:sldMkLst>
-          <pc:docMk/>
-          <pc:sldMk cId="1167696200" sldId="262"/>
-        </pc:sldMkLst>
-      </pc:sldChg>
-      <pc:sldChg chg="del">
-        <pc:chgData name="Riccardo Berta" userId="c8694f89-bba4-4576-b0a8-456619ca5a8c" providerId="ADAL" clId="{89457721-8AF9-BB44-BAF2-46F7B0D7D7E8}" dt="2022-08-30T09:54:27.400" v="22" actId="2696"/>
-        <pc:sldMkLst>
-          <pc:docMk/>
-          <pc:sldMk cId="11402927" sldId="263"/>
-        </pc:sldMkLst>
-      </pc:sldChg>
-      <pc:sldChg chg="modSp add mod">
-        <pc:chgData name="Riccardo Berta" userId="c8694f89-bba4-4576-b0a8-456619ca5a8c" providerId="ADAL" clId="{89457721-8AF9-BB44-BAF2-46F7B0D7D7E8}" dt="2022-08-30T09:55:24.863" v="44" actId="20577"/>
-        <pc:sldMkLst>
-          <pc:docMk/>
-          <pc:sldMk cId="1817587258" sldId="263"/>
-        </pc:sldMkLst>
-      </pc:sldChg>
-      <pc:sldChg chg="del">
-        <pc:chgData name="Riccardo Berta" userId="c8694f89-bba4-4576-b0a8-456619ca5a8c" providerId="ADAL" clId="{89457721-8AF9-BB44-BAF2-46F7B0D7D7E8}" dt="2022-08-30T09:54:27.959" v="23" actId="2696"/>
-        <pc:sldMkLst>
-          <pc:docMk/>
-          <pc:sldMk cId="2794482370" sldId="264"/>
-        </pc:sldMkLst>
+            <pc:sldMk cId="0" sldId="257"/>
+            <ac:picMk id="3" creationId="{7C3A0E80-63B4-43A9-288E-9ED466FF95EB}"/>
+          </ac:picMkLst>
+        </pc:picChg>
       </pc:sldChg>
     </pc:docChg>
   </pc:docChgLst>
@@ -13168,14 +11896,28 @@
             </a:r>
           </a:p>
           <a:p>
-            <a:pPr lvl="1"/>
+            <a:pPr lvl="1">
+              <a:spcBef>
+                <a:spcPts val="0"/>
+              </a:spcBef>
+              <a:spcAft>
+                <a:spcPts val="0"/>
+              </a:spcAft>
+            </a:pPr>
             <a:r>
               <a:rPr lang="en-GB" dirty="0"/>
               <a:t>from picking out our meals…</a:t>
             </a:r>
           </a:p>
           <a:p>
-            <a:pPr lvl="1"/>
+            <a:pPr lvl="1">
+              <a:spcBef>
+                <a:spcPts val="0"/>
+              </a:spcBef>
+              <a:spcAft>
+                <a:spcPts val="0"/>
+              </a:spcAft>
+            </a:pPr>
             <a:r>
               <a:rPr lang="en-GB" dirty="0"/>
               <a:t>…to advancing our careers</a:t>
@@ -13204,59 +11946,13 @@
             </a:r>
           </a:p>
           <a:p>
-            <a:pPr lvl="1"/>
-            <a:r>
-              <a:rPr lang="en-GB" b="1" dirty="0"/>
-              <a:t>immediate gratification </a:t>
-            </a:r>
-            <a:r>
-              <a:rPr lang="en-GB" dirty="0"/>
-              <a:t>or </a:t>
-            </a:r>
-            <a:r>
-              <a:rPr lang="en-GB" b="1" dirty="0"/>
-              <a:t>long-term success</a:t>
-            </a:r>
-          </a:p>
-          <a:p>
-            <a:pPr lvl="1"/>
-            <a:r>
-              <a:rPr lang="en-GB" dirty="0"/>
-              <a:t>they’re still our perception of how </a:t>
-            </a:r>
-            <a:r>
-              <a:rPr lang="en-GB" b="1" dirty="0"/>
-              <a:t>important</a:t>
-            </a:r>
-            <a:r>
-              <a:rPr lang="en-GB" dirty="0"/>
-              <a:t> and </a:t>
-            </a:r>
-            <a:r>
-              <a:rPr lang="en-GB" b="1" dirty="0"/>
-              <a:t>valuable</a:t>
-            </a:r>
-            <a:r>
-              <a:rPr lang="en-GB" dirty="0"/>
-              <a:t> they are</a:t>
-            </a:r>
-          </a:p>
-          <a:p>
-            <a:r>
-              <a:rPr lang="en-GB" dirty="0"/>
-              <a:t>The ability to achieve these precious moments seems to be correlated with </a:t>
-            </a:r>
-            <a:r>
-              <a:rPr lang="en-GB" b="1" dirty="0"/>
-              <a:t>intelligence</a:t>
-            </a:r>
-          </a:p>
-          <a:p>
-            <a:pPr lvl="1"/>
-            <a:r>
-              <a:rPr lang="en-GB" dirty="0"/>
-              <a:t>the ability to acquire and apply knowledge and skills</a:t>
-            </a:r>
+            <a:endParaRPr lang="en-GB" dirty="0"/>
+          </a:p>
+          <a:p>
+            <a:endParaRPr lang="en-GB" dirty="0"/>
+          </a:p>
+          <a:p>
+            <a:endParaRPr lang="en-GB" dirty="0"/>
           </a:p>
           <a:p>
             <a:endParaRPr lang="en-GB" dirty="0"/>
@@ -13276,21 +11972,42 @@
             </a:r>
           </a:p>
           <a:p>
-            <a:pPr lvl="1"/>
+            <a:pPr lvl="1">
+              <a:spcBef>
+                <a:spcPts val="0"/>
+              </a:spcBef>
+              <a:spcAft>
+                <a:spcPts val="0"/>
+              </a:spcAft>
+            </a:pPr>
             <a:r>
               <a:rPr lang="en-GB" dirty="0"/>
               <a:t>no human labels data</a:t>
             </a:r>
           </a:p>
           <a:p>
-            <a:pPr lvl="1"/>
+            <a:pPr lvl="1">
+              <a:spcBef>
+                <a:spcPts val="0"/>
+              </a:spcBef>
+              <a:spcAft>
+                <a:spcPts val="0"/>
+              </a:spcAft>
+            </a:pPr>
             <a:r>
               <a:rPr lang="en-GB" dirty="0"/>
               <a:t>no human collects or explicitly designs the collection of data</a:t>
             </a:r>
           </a:p>
           <a:p>
-            <a:pPr lvl="1"/>
+            <a:pPr lvl="1">
+              <a:spcBef>
+                <a:spcPts val="0"/>
+              </a:spcBef>
+              <a:spcAft>
+                <a:spcPts val="0"/>
+              </a:spcAft>
+            </a:pPr>
             <a:r>
               <a:rPr lang="en-GB" dirty="0"/>
               <a:t>the goal in RL is </a:t>
@@ -13314,6 +12031,36 @@
           </a:p>
         </p:txBody>
       </p:sp>
+      <p:pic>
+        <p:nvPicPr>
+          <p:cNvPr id="3" name="Immagine 2">
+            <a:extLst>
+              <a:ext uri="{FF2B5EF4-FFF2-40B4-BE49-F238E27FC236}">
+                <a16:creationId xmlns:a16="http://schemas.microsoft.com/office/drawing/2014/main" id="{7C3A0E80-63B4-43A9-288E-9ED466FF95EB}"/>
+              </a:ext>
+            </a:extLst>
+          </p:cNvPr>
+          <p:cNvPicPr>
+            <a:picLocks noChangeAspect="1"/>
+          </p:cNvPicPr>
+          <p:nvPr/>
+        </p:nvPicPr>
+        <p:blipFill>
+          <a:blip r:embed="rId3"/>
+          <a:stretch>
+            <a:fillRect/>
+          </a:stretch>
+        </p:blipFill>
+        <p:spPr>
+          <a:xfrm>
+            <a:off x="1208850" y="4333700"/>
+            <a:ext cx="7772400" cy="3023949"/>
+          </a:xfrm>
+          <a:prstGeom prst="rect">
+            <a:avLst/>
+          </a:prstGeom>
+        </p:spPr>
+      </p:pic>
     </p:spTree>
   </p:cSld>
   <p:clrMapOvr>
@@ -15166,15 +13913,6 @@
 </file>
 
 <file path=customXml/item2.xml><?xml version="1.0" encoding="utf-8"?>
-<?mso-contentType ?>
-<FormTemplates xmlns="http://schemas.microsoft.com/sharepoint/v3/contenttype/forms">
-  <Display>DocumentLibraryForm</Display>
-  <Edit>DocumentLibraryForm</Edit>
-  <New>DocumentLibraryForm</New>
-</FormTemplates>
-</file>
-
-<file path=customXml/item3.xml><?xml version="1.0" encoding="utf-8"?>
 <p:properties xmlns:p="http://schemas.microsoft.com/office/2006/metadata/properties" xmlns:xsi="http://www.w3.org/2001/XMLSchema-instance" xmlns:pc="http://schemas.microsoft.com/office/infopath/2007/PartnerControls">
   <documentManagement>
     <TaxCatchAll xmlns="e9b5433c-2372-4cb7-8bab-09518096b29b" xsi:nil="true"/>
@@ -15183,6 +13921,15 @@
     </lcf76f155ced4ddcb4097134ff3c332f>
   </documentManagement>
 </p:properties>
+</file>
+
+<file path=customXml/item3.xml><?xml version="1.0" encoding="utf-8"?>
+<?mso-contentType ?>
+<FormTemplates xmlns="http://schemas.microsoft.com/sharepoint/v3/contenttype/forms">
+  <Display>DocumentLibraryForm</Display>
+  <Edit>DocumentLibraryForm</Edit>
+  <New>DocumentLibraryForm</New>
+</FormTemplates>
 </file>
 
 <file path=customXml/itemProps1.xml><?xml version="1.0" encoding="utf-8"?>
@@ -15205,26 +13952,26 @@
 </file>
 
 <file path=customXml/itemProps2.xml><?xml version="1.0" encoding="utf-8"?>
+<ds:datastoreItem xmlns:ds="http://schemas.openxmlformats.org/officeDocument/2006/customXml" ds:itemID="{5CCE7217-A2D6-456E-853C-D4A15542B293}">
+  <ds:schemaRefs>
+    <ds:schemaRef ds:uri="http://purl.org/dc/dcmitype/"/>
+    <ds:schemaRef ds:uri="3bd0d43f-5e5b-43cd-b6fc-691bd77672c6"/>
+    <ds:schemaRef ds:uri="http://schemas.microsoft.com/office/2006/documentManagement/types"/>
+    <ds:schemaRef ds:uri="http://www.w3.org/XML/1998/namespace"/>
+    <ds:schemaRef ds:uri="http://purl.org/dc/terms/"/>
+    <ds:schemaRef ds:uri="http://schemas.microsoft.com/office/infopath/2007/PartnerControls"/>
+    <ds:schemaRef ds:uri="http://schemas.openxmlformats.org/package/2006/metadata/core-properties"/>
+    <ds:schemaRef ds:uri="e9b5433c-2372-4cb7-8bab-09518096b29b"/>
+    <ds:schemaRef ds:uri="http://schemas.microsoft.com/office/2006/metadata/properties"/>
+    <ds:schemaRef ds:uri="http://purl.org/dc/elements/1.1/"/>
+  </ds:schemaRefs>
+</ds:datastoreItem>
+</file>
+
+<file path=customXml/itemProps3.xml><?xml version="1.0" encoding="utf-8"?>
 <ds:datastoreItem xmlns:ds="http://schemas.openxmlformats.org/officeDocument/2006/customXml" ds:itemID="{9A30388A-CCF7-4970-A513-DBB915DFEE8F}">
   <ds:schemaRefs>
     <ds:schemaRef ds:uri="http://schemas.microsoft.com/sharepoint/v3/contenttype/forms"/>
   </ds:schemaRefs>
 </ds:datastoreItem>
-</file>
-
-<file path=customXml/itemProps3.xml><?xml version="1.0" encoding="utf-8"?>
-<ds:datastoreItem xmlns:ds="http://schemas.openxmlformats.org/officeDocument/2006/customXml" ds:itemID="{5CCE7217-A2D6-456E-853C-D4A15542B293}">
-  <ds:schemaRefs>
-    <ds:schemaRef ds:uri="http://schemas.microsoft.com/office/2006/documentManagement/types"/>
-    <ds:schemaRef ds:uri="3bd0d43f-5e5b-43cd-b6fc-691bd77672c6"/>
-    <ds:schemaRef ds:uri="http://www.w3.org/XML/1998/namespace"/>
-    <ds:schemaRef ds:uri="http://purl.org/dc/elements/1.1/"/>
-    <ds:schemaRef ds:uri="e9b5433c-2372-4cb7-8bab-09518096b29b"/>
-    <ds:schemaRef ds:uri="http://purl.org/dc/dcmitype/"/>
-    <ds:schemaRef ds:uri="http://purl.org/dc/terms/"/>
-    <ds:schemaRef ds:uri="http://schemas.microsoft.com/office/infopath/2007/PartnerControls"/>
-    <ds:schemaRef ds:uri="http://schemas.openxmlformats.org/package/2006/metadata/core-properties"/>
-    <ds:schemaRef ds:uri="http://schemas.microsoft.com/office/2006/metadata/properties"/>
-  </ds:schemaRefs>
-</ds:datastoreItem>
 </file>
</xml_diff>